<commit_message>
Tailor content to Japanese draft, implement Slide 4 automatic video transitions, split Slide 4/5 in PPT
</commit_message>
<xml_diff>
--- a/seibi_presentation.pptx
+++ b/seibi_presentation.pptx
@@ -3130,7 +3130,7 @@
                 <a:solidFill>
                   <a:srgbClr val="3B82F6"/>
                 </a:solidFill>
-                <a:latin typeface="Segoe UI"/>
+                <a:latin typeface="Yu Gothic"/>
               </a:defRPr>
             </a:pPr>
             <a:r>
@@ -3146,11 +3146,11 @@
                 <a:solidFill>
                   <a:srgbClr val="F3F4F6"/>
                 </a:solidFill>
-                <a:latin typeface="Segoe UI"/>
+                <a:latin typeface="Yu Gothic"/>
               </a:defRPr>
             </a:pPr>
             <a:r>
-              <a:t>設備管理システム — Equipment Maintenance &amp; Inspection Management</a:t>
+              <a:t>設備管理システム — 設備点検アプリのご紹介</a:t>
             </a:r>
           </a:p>
         </p:txBody>
@@ -3182,11 +3182,11 @@
                 <a:solidFill>
                   <a:srgbClr val="9CA3AF"/>
                 </a:solidFill>
-                <a:latin typeface="Segoe UI"/>
+                <a:latin typeface="Yu Gothic"/>
               </a:defRPr>
             </a:pPr>
             <a:r>
-              <a:t>A Premium Digital Solution for Factory Maintenance Operations</a:t>
+              <a:t>紙ベースの点検作業から、リアルタイム共有、AIによる現場修理サポートへ</a:t>
             </a:r>
           </a:p>
           <a:p>
@@ -3198,11 +3198,11 @@
                 <a:solidFill>
                   <a:srgbClr val="10B981"/>
                 </a:solidFill>
-                <a:latin typeface="Segoe UI"/>
+                <a:latin typeface="Yu Gothic"/>
               </a:defRPr>
             </a:pPr>
             <a:r>
-              <a:t>Prepared by Antigravity AI</a:t>
+              <a:t>Antigravity AI によってカスタマイズ</a:t>
             </a:r>
           </a:p>
         </p:txBody>
@@ -3260,11 +3260,11 @@
                 <a:solidFill>
                   <a:srgbClr val="3B82F6"/>
                 </a:solidFill>
-                <a:latin typeface="Segoe UI"/>
+                <a:latin typeface="Yu Gothic"/>
               </a:defRPr>
             </a:pPr>
             <a:r>
-              <a:t>The Challenge in Factory Maintenance</a:t>
+              <a:t>1. 導入の経緯と従来の課題</a:t>
             </a:r>
           </a:p>
         </p:txBody>
@@ -3299,11 +3299,11 @@
                 <a:solidFill>
                   <a:srgbClr val="F3F4F6"/>
                 </a:solidFill>
-                <a:latin typeface="Segoe UI"/>
+                <a:latin typeface="Yu Gothic"/>
               </a:defRPr>
             </a:pPr>
             <a:r>
-              <a:t>❌ Lack of Visibility: Factory managers cannot see real-time machine health rates (e.g. only 33% operating normally).</a:t>
+              <a:t>❌ 履歴が残らない: 全て手書きの紙で点検を行い、提出後はファイル保管か処分するのみで検索できない。</a:t>
             </a:r>
           </a:p>
           <a:p>
@@ -3315,11 +3315,11 @@
                 <a:solidFill>
                   <a:srgbClr val="F3F4F6"/>
                 </a:solidFill>
-                <a:latin typeface="Segoe UI"/>
+                <a:latin typeface="Yu Gothic"/>
               </a:defRPr>
             </a:pPr>
             <a:r>
-              <a:t>❌ Hard to Track Progress: Paper-based checklists lead to missed tasks (e.g. 0/13 daily tasks completed).</a:t>
+              <a:t>❌ 過去の状況が不明: 過去の不具合や前月・去年の状況を確認する手段がなかった。</a:t>
             </a:r>
           </a:p>
           <a:p>
@@ -3331,27 +3331,11 @@
                 <a:solidFill>
                   <a:srgbClr val="F3F4F6"/>
                 </a:solidFill>
-                <a:latin typeface="Segoe UI"/>
+                <a:latin typeface="Yu Gothic"/>
               </a:defRPr>
             </a:pPr>
             <a:r>
-              <a:t>❌ Siloed Communications: Issues reported on paper remain hidden, causing delayed repairs.</a:t>
-            </a:r>
-          </a:p>
-          <a:p>
-            <a:pPr>
-              <a:spcAft>
-                <a:spcPts val="1000"/>
-              </a:spcAft>
-              <a:defRPr sz="1400">
-                <a:solidFill>
-                  <a:srgbClr val="F3F4F6"/>
-                </a:solidFill>
-                <a:latin typeface="Segoe UI"/>
-              </a:defRPr>
-            </a:pPr>
-            <a:r>
-              <a:t>❌ Inaccessible Manuals: Operators waste time searching for printed manuals during a breakdown.</a:t>
+              <a:t>❌ 状況のブラックボックス化: 点検表を持っている技術者本人以外には、設備の稼働・不具合状況が見えない。</a:t>
             </a:r>
           </a:p>
         </p:txBody>
@@ -3386,11 +3370,11 @@
                 <a:solidFill>
                   <a:srgbClr val="F3F4F6"/>
                 </a:solidFill>
-                <a:latin typeface="Segoe UI"/>
+                <a:latin typeface="Yu Gothic"/>
               </a:defRPr>
             </a:pPr>
             <a:r>
-              <a:t>✅ Real-Time Dashboards: Immediate status tracking for workers and managers.</a:t>
+              <a:t>⚠️ 記憶頼みの点検: 同じ不具合が繰り返し起きていても、個人の記憶に頼らざるを得なかった。</a:t>
             </a:r>
           </a:p>
           <a:p>
@@ -3402,11 +3386,11 @@
                 <a:solidFill>
                   <a:srgbClr val="F3F4F6"/>
                 </a:solidFill>
-                <a:latin typeface="Segoe UI"/>
+                <a:latin typeface="Yu Gothic"/>
               </a:defRPr>
             </a:pPr>
             <a:r>
-              <a:t>✅ Interactive Factory Maps: Visual wiring layouts and instant equipment health checks.</a:t>
+              <a:t>⚠️ 修理状況の追跡不可: 不具合を発見しても、実際に修理が完了したかを追跡する仕組みがない。</a:t>
             </a:r>
           </a:p>
           <a:p>
@@ -3418,27 +3402,11 @@
                 <a:solidFill>
                   <a:srgbClr val="F3F4F6"/>
                 </a:solidFill>
-                <a:latin typeface="Segoe UI"/>
+                <a:latin typeface="Yu Gothic"/>
               </a:defRPr>
             </a:pPr>
             <a:r>
-              <a:t>✅ Collaborative Logs &amp; Chat: Streamlined reporting and direct communication.</a:t>
-            </a:r>
-          </a:p>
-          <a:p>
-            <a:pPr>
-              <a:spcAft>
-                <a:spcPts val="1000"/>
-              </a:spcAft>
-              <a:defRPr sz="1400">
-                <a:solidFill>
-                  <a:srgbClr val="F3F4F6"/>
-                </a:solidFill>
-                <a:latin typeface="Segoe UI"/>
-              </a:defRPr>
-            </a:pPr>
-            <a:r>
-              <a:t>✅ AI-Powered Manuals: On-demand answers for immediate troubleshooting.</a:t>
+              <a:t>⚠️ マニュアルの検索性悪化: 作業中に手順を確認する際、分厚い紙マニュアルをめくるか周りに聞くしかなかった。</a:t>
             </a:r>
           </a:p>
         </p:txBody>
@@ -3496,11 +3464,11 @@
                 <a:solidFill>
                   <a:srgbClr val="3B82F6"/>
                 </a:solidFill>
-                <a:latin typeface="Segoe UI"/>
+                <a:latin typeface="Yu Gothic"/>
               </a:defRPr>
             </a:pPr>
             <a:r>
-              <a:t>Worker Dashboard: Simple &amp; Action-Oriented</a:t>
+              <a:t>2. 解決策 (1) 点検作業のデジタル化</a:t>
             </a:r>
           </a:p>
         </p:txBody>
@@ -3535,11 +3503,11 @@
                 <a:solidFill>
                   <a:srgbClr val="F3F4F6"/>
                 </a:solidFill>
-                <a:latin typeface="Segoe UI"/>
+                <a:latin typeface="Yu Gothic"/>
               </a:defRPr>
             </a:pPr>
             <a:r>
-              <a:t>📊 Task Progress Meter: Simple visualization showing total tasks done vs remaining (0/13 completed).</a:t>
+              <a:t>📱 モバイル端末での入力: タブレットやスマートフォンを使い、現場で即座に点検表を入力・提出可能。</a:t>
             </a:r>
           </a:p>
           <a:p>
@@ -3551,11 +3519,11 @@
                 <a:solidFill>
                   <a:srgbClr val="F3F4F6"/>
                 </a:solidFill>
-                <a:latin typeface="Segoe UI"/>
+                <a:latin typeface="Yu Gothic"/>
               </a:defRPr>
             </a:pPr>
             <a:r>
-              <a:t>⚠️ Abnormality Tracker: Bold red counts highlighting active issues ('3' requiring action).</a:t>
+              <a:t>🔍 検索可能な履歴保存: 提出されたデータは自動蓄積され、過去の不具合履歴をいつでも検索・確認できるように。</a:t>
             </a:r>
           </a:p>
           <a:p>
@@ -3567,27 +3535,11 @@
                 <a:solidFill>
                   <a:srgbClr val="F3F4F6"/>
                 </a:solidFill>
-                <a:latin typeface="Segoe UI"/>
+                <a:latin typeface="Yu Gothic"/>
               </a:defRPr>
             </a:pPr>
             <a:r>
-              <a:t>⚙️ Overall Equipment Health: Live calculation of working machines (33% health rate).</a:t>
-            </a:r>
-          </a:p>
-          <a:p>
-            <a:pPr>
-              <a:spcAft>
-                <a:spcPts val="1000"/>
-              </a:spcAft>
-              <a:defRPr sz="1400">
-                <a:solidFill>
-                  <a:srgbClr val="F3F4F6"/>
-                </a:solidFill>
-                <a:latin typeface="Segoe UI"/>
-              </a:defRPr>
-            </a:pPr>
-            <a:r>
-              <a:t>📅 Overdue Inspector Alerts: Red-bordered prioritized cards for monthly checks and repairs.</a:t>
+              <a:t>📊 稼働ダッシュボード: 今日のタスク進捗（例：0/13件完了）、異常発生件数、全体設備健全率を可視化。</a:t>
             </a:r>
           </a:p>
         </p:txBody>
@@ -3669,11 +3621,11 @@
                 <a:solidFill>
                   <a:srgbClr val="3B82F6"/>
                 </a:solidFill>
-                <a:latin typeface="Segoe UI"/>
+                <a:latin typeface="Yu Gothic"/>
               </a:defRPr>
             </a:pPr>
             <a:r>
-              <a:t>Floor Layout &amp; Interactive Wire Map</a:t>
+              <a:t>2. 解決策 (2) 現場マップでの視覚的管理</a:t>
             </a:r>
           </a:p>
         </p:txBody>
@@ -3708,11 +3660,11 @@
                 <a:solidFill>
                   <a:srgbClr val="F3F4F6"/>
                 </a:solidFill>
-                <a:latin typeface="Segoe UI"/>
+                <a:latin typeface="Yu Gothic"/>
               </a:defRPr>
             </a:pPr>
             <a:r>
-              <a:t>📍 Interactive Blueprint: Visual layout mapping out TIG/CO2 Welders, Robots, Weld Tables, Controllers, and Gas Tanks.</a:t>
+              <a:t>🗺️ インタラクティブ平面図: 工場内の溶接機やロボット、制御盤、ガスタンク等の配置を地図上で確認可能。</a:t>
             </a:r>
           </a:p>
           <a:p>
@@ -3724,11 +3676,11 @@
                 <a:solidFill>
                   <a:srgbClr val="F3F4F6"/>
                 </a:solidFill>
-                <a:latin typeface="Segoe UI"/>
+                <a:latin typeface="Yu Gothic"/>
               </a:defRPr>
             </a:pPr>
             <a:r>
-              <a:t>⚡ Status Indicators: Color-coded nodes (Orange for robots, Blue for controllers, Cyan for weld tables).</a:t>
+              <a:t>🔌 配線ルートの確認: 設備をタップするだけで、給電や通信の配線ルートをビジュアル表示。</a:t>
             </a:r>
           </a:p>
           <a:p>
@@ -3740,27 +3692,11 @@
                 <a:solidFill>
                   <a:srgbClr val="F3F4F6"/>
                 </a:solidFill>
-                <a:latin typeface="Segoe UI"/>
+                <a:latin typeface="Yu Gothic"/>
               </a:defRPr>
             </a:pPr>
             <a:r>
-              <a:t>🔌 Wiring Overlay: Allows workers to tap on machines to inspect connection paths instantly.</a:t>
-            </a:r>
-          </a:p>
-          <a:p>
-            <a:pPr>
-              <a:spcAft>
-                <a:spcPts val="1000"/>
-              </a:spcAft>
-              <a:defRPr sz="1400">
-                <a:solidFill>
-                  <a:srgbClr val="F3F4F6"/>
-                </a:solidFill>
-                <a:latin typeface="Segoe UI"/>
-              </a:defRPr>
-            </a:pPr>
-            <a:r>
-              <a:t>📋 Inspection Planning: Single button access to '点検予定配線' (Scheduled Inspection Wiring) to view upcoming routes.</a:t>
+              <a:t>⚡ 直感的なトラブルシューティング: 異常が発生しているノードを素早く特定し、影響範囲を判断。</a:t>
             </a:r>
           </a:p>
         </p:txBody>
@@ -3842,11 +3778,11 @@
                 <a:solidFill>
                   <a:srgbClr val="3B82F6"/>
                 </a:solidFill>
-                <a:latin typeface="Segoe UI"/>
+                <a:latin typeface="Yu Gothic"/>
               </a:defRPr>
             </a:pPr>
             <a:r>
-              <a:t>Audit Trails &amp; Inspection History Logs</a:t>
+              <a:t>2. 解決策 (3) 点検・修理履歴の監査ログ</a:t>
             </a:r>
           </a:p>
         </p:txBody>
@@ -3881,11 +3817,11 @@
                 <a:solidFill>
                   <a:srgbClr val="F3F4F6"/>
                 </a:solidFill>
-                <a:latin typeface="Segoe UI"/>
+                <a:latin typeface="Yu Gothic"/>
               </a:defRPr>
             </a:pPr>
             <a:r>
-              <a:t>📜 Comprehensive History Log: List of completed inspection entries showing dates, technicians, and outcomes.</a:t>
+              <a:t>📋 包括的な履歴ログ: 過去に実施した点検結果、不具合の内容、作業担当者をタイムスタンプ付きで記録。</a:t>
             </a:r>
           </a:p>
           <a:p>
@@ -3897,11 +3833,11 @@
                 <a:solidFill>
                   <a:srgbClr val="F3F4F6"/>
                 </a:solidFill>
-                <a:latin typeface="Segoe UI"/>
+                <a:latin typeface="Yu Gothic"/>
               </a:defRPr>
             </a:pPr>
             <a:r>
-              <a:t>🔍 Flexible Filtering: Easy filtering by Date, Equipment, Time Period (30/90 days), and Status (Normal/Repair/Abnormality).</a:t>
+              <a:t>🔍 多彩なフィルタ機能: 日付順、設備順、期間（30日〜今年）やステータス（異常ありなど）で瞬時に絞り込み可能。</a:t>
             </a:r>
           </a:p>
           <a:p>
@@ -3913,11 +3849,11 @@
                 <a:solidFill>
                   <a:srgbClr val="F3F4F6"/>
                 </a:solidFill>
-                <a:latin typeface="Segoe UI"/>
+                <a:latin typeface="Yu Gothic"/>
               </a:defRPr>
             </a:pPr>
             <a:r>
-              <a:t>📊 High-Level Stats: Clear metrics summing up total inspections, repairs, and abnormalities discovered in a given window.</a:t>
+              <a:t>📈 修理進捗の追跡: 不具合に対する修理が完了しているかをデジタル上で管理し、対応漏れを防ぐ。</a:t>
             </a:r>
           </a:p>
         </p:txBody>
@@ -3999,11 +3935,11 @@
                 <a:solidFill>
                   <a:srgbClr val="3B82F6"/>
                 </a:solidFill>
-                <a:latin typeface="Segoe UI"/>
+                <a:latin typeface="Yu Gothic"/>
               </a:defRPr>
             </a:pPr>
             <a:r>
-              <a:t>Bulletin Board: Communication &amp; Quick Action</a:t>
+              <a:t>2. 解決策 (4) リアルタイム状況共有・タスク化</a:t>
             </a:r>
           </a:p>
         </p:txBody>
@@ -4038,11 +3974,11 @@
                 <a:solidFill>
                   <a:srgbClr val="F3F4F6"/>
                 </a:solidFill>
-                <a:latin typeface="Segoe UI"/>
+                <a:latin typeface="Yu Gothic"/>
               </a:defRPr>
             </a:pPr>
             <a:r>
-              <a:t>💬 Integrated Incident Feed: Stream of reports directly from operators on the floor.</a:t>
+              <a:t>🚨 自動タスク登録 &amp; 通知: 不具合検知時、システムが自動的に修理タスクを作成し関係者に通知。</a:t>
             </a:r>
           </a:p>
           <a:p>
@@ -4054,11 +3990,11 @@
                 <a:solidFill>
                   <a:srgbClr val="F3F4F6"/>
                 </a:solidFill>
-                <a:latin typeface="Segoe UI"/>
+                <a:latin typeface="Yu Gothic"/>
               </a:defRPr>
             </a:pPr>
             <a:r>
-              <a:t>🛠️ Actionable Items: '修理開始' (Start Repair) button right in the feed, enabling immediate response.</a:t>
+              <a:t>💬 チャット・掲示板機能: 異常内容に対して、現場から「修理開始 (修理開始)」ボタンで即座に担当宣言が可能。</a:t>
             </a:r>
           </a:p>
           <a:p>
@@ -4070,27 +4006,11 @@
                 <a:solidFill>
                   <a:srgbClr val="F3F4F6"/>
                 </a:solidFill>
-                <a:latin typeface="Segoe UI"/>
+                <a:latin typeface="Yu Gothic"/>
               </a:defRPr>
             </a:pPr>
             <a:r>
-              <a:t>🚨 Categorized Reports: Messages labeled with icons for Safety (安全), Warnings (警告), and Abnormalities (異常).</a:t>
-            </a:r>
-          </a:p>
-          <a:p>
-            <a:pPr>
-              <a:spcAft>
-                <a:spcPts val="1000"/>
-              </a:spcAft>
-              <a:defRPr sz="1400">
-                <a:solidFill>
-                  <a:srgbClr val="F3F4F6"/>
-                </a:solidFill>
-                <a:latin typeface="Segoe UI"/>
-              </a:defRPr>
-            </a:pPr>
-            <a:r>
-              <a:t>✍️ Quick Communication: Bottom text field for posting real-time announcements.</a:t>
+              <a:t>🔗 社内連絡ツールとの自動連携: 重大な不具合の場合は、社内チャットツールへ自動で警告通知を送信。</a:t>
             </a:r>
           </a:p>
         </p:txBody>
@@ -4172,11 +4092,11 @@
                 <a:solidFill>
                   <a:srgbClr val="3B82F6"/>
                 </a:solidFill>
-                <a:latin typeface="Segoe UI"/>
+                <a:latin typeface="Yu Gothic"/>
               </a:defRPr>
             </a:pPr>
             <a:r>
-              <a:t>Maintenance Manuals with AI Search</a:t>
+              <a:t>2. 解決策 (5) AIによる現場修理サポート</a:t>
             </a:r>
           </a:p>
         </p:txBody>
@@ -4211,11 +4131,11 @@
                 <a:solidFill>
                   <a:srgbClr val="F3F4F6"/>
                 </a:solidFill>
-                <a:latin typeface="Segoe UI"/>
+                <a:latin typeface="Yu Gothic"/>
               </a:defRPr>
             </a:pPr>
             <a:r>
-              <a:t>💡 Smart Search Box: Operators input complex machine symptoms (e.g. 'J3 joint vibrating').</a:t>
+              <a:t>🤖 自然言語での質問: 分厚いマニュアルをめくる代わりに、普段の言葉で質問可能（例：「J3関節で異音、ロボットアームが震えている」）。</a:t>
             </a:r>
           </a:p>
           <a:p>
@@ -4227,11 +4147,11 @@
                 <a:solidFill>
                   <a:srgbClr val="F3F4F6"/>
                 </a:solidFill>
-                <a:latin typeface="Segoe UI"/>
+                <a:latin typeface="Yu Gothic"/>
               </a:defRPr>
             </a:pPr>
             <a:r>
-              <a:t>🤖 AI Q&amp;A Integration: Provides immediate step-by-step instructions from local manuals.</a:t>
+              <a:t>📖 引用元の提示: AIが関連するマニュアル部分を特定し、「どの箇所の記述か」を示しながら的確に回答。</a:t>
             </a:r>
           </a:p>
           <a:p>
@@ -4243,27 +4163,11 @@
                 <a:solidFill>
                   <a:srgbClr val="F3F4F6"/>
                 </a:solidFill>
-                <a:latin typeface="Segoe UI"/>
+                <a:latin typeface="Yu Gothic"/>
               </a:defRPr>
             </a:pPr>
             <a:r>
-              <a:t>📖 Grouped Procedures: Categorized documentation for easy manual selection (Grinders, CO2 Welding Robots).</a:t>
-            </a:r>
-          </a:p>
-          <a:p>
-            <a:pPr>
-              <a:spcAft>
-                <a:spcPts val="1000"/>
-              </a:spcAft>
-              <a:defRPr sz="1400">
-                <a:solidFill>
-                  <a:srgbClr val="F3F4F6"/>
-                </a:solidFill>
-                <a:latin typeface="Segoe UI"/>
-              </a:defRPr>
-            </a:pPr>
-            <a:r>
-              <a:t>📉 Reduced Downtime: Ensures workers have immediate access to resolutions without waiting for senior technicians.</a:t>
+              <a:t>⚙️ カテゴリ別の構成: グラインダやCO2溶接ロボットなどのハードウェアごとに整理された手順書へ素早くアクセス。</a:t>
             </a:r>
           </a:p>
         </p:txBody>
@@ -4345,11 +4249,11 @@
                 <a:solidFill>
                   <a:srgbClr val="3B82F6"/>
                 </a:solidFill>
-                <a:latin typeface="Segoe UI"/>
+                <a:latin typeface="Yu Gothic"/>
               </a:defRPr>
             </a:pPr>
             <a:r>
-              <a:t>The Value of Seibi App</a:t>
+              <a:t>3. 成果と今後の展望</a:t>
             </a:r>
           </a:p>
         </p:txBody>
@@ -4384,11 +4288,27 @@
                 <a:solidFill>
                   <a:srgbClr val="F3F4F6"/>
                 </a:solidFill>
-                <a:latin typeface="Segoe UI"/>
+                <a:latin typeface="Yu Gothic"/>
               </a:defRPr>
             </a:pPr>
             <a:r>
-              <a:t>Simplifies task checklists for technicians. Direct reporting prevents missed maintenance tasks and ensures smooth operations.</a:t>
+              <a:t>開発はすべて完了し、現在は本格運用に向けた最終確認段階。</a:t>
+            </a:r>
+          </a:p>
+          <a:p>
+            <a:pPr>
+              <a:spcAft>
+                <a:spcPts val="1000"/>
+              </a:spcAft>
+              <a:defRPr sz="1400">
+                <a:solidFill>
+                  <a:srgbClr val="F3F4F6"/>
+                </a:solidFill>
+                <a:latin typeface="Yu Gothic"/>
+              </a:defRPr>
+            </a:pPr>
+            <a:r>
+              <a:t>紙廃止による履歴の蓄積、自動通知による迅速な初動、マニュアル検索時間のゼロ化による修理時間の大幅短縮を見込む。</a:t>
             </a:r>
           </a:p>
         </p:txBody>
@@ -4423,11 +4343,11 @@
                 <a:solidFill>
                   <a:srgbClr val="F3F4F6"/>
                 </a:solidFill>
-                <a:latin typeface="Segoe UI"/>
+                <a:latin typeface="Yu Gothic"/>
               </a:defRPr>
             </a:pPr>
             <a:r>
-              <a:t>Real-time bulletin board and 'Start Repair' button reduce communication lag. Machine problems are addressed immediately.</a:t>
+              <a:t>現在は一部の設備のみ対応しているマニュアルの範囲を広げ、工場内のすべての主要設備でAIサポートを利用可能に。</a:t>
             </a:r>
           </a:p>
         </p:txBody>
@@ -4462,11 +4382,27 @@
                 <a:solidFill>
                   <a:srgbClr val="F3F4F6"/>
                 </a:solidFill>
-                <a:latin typeface="Segoe UI"/>
+                <a:latin typeface="Yu Gothic"/>
               </a:defRPr>
             </a:pPr>
             <a:r>
-              <a:t>Visual Floor Map removes guesswork. Inspectors see the exact location and wiring path of the malfunctioning unit.</a:t>
+              <a:t>技術者がAIにした質問と、その回答が役に立ったかどうかのフィードバックをログ化。</a:t>
+            </a:r>
+          </a:p>
+          <a:p>
+            <a:pPr>
+              <a:spcAft>
+                <a:spcPts val="1000"/>
+              </a:spcAft>
+              <a:defRPr sz="1400">
+                <a:solidFill>
+                  <a:srgbClr val="F3F4F6"/>
+                </a:solidFill>
+                <a:latin typeface="Yu Gothic"/>
+              </a:defRPr>
+            </a:pPr>
+            <a:r>
+              <a:t>有効な回答パターンを蓄積し、現場の利用実績に応じてAIの回答精度が自動で向上するエコシステムを構築。</a:t>
             </a:r>
           </a:p>
         </p:txBody>
@@ -4501,11 +4437,11 @@
                 <a:solidFill>
                   <a:srgbClr val="F3F4F6"/>
                 </a:solidFill>
-                <a:latin typeface="Segoe UI"/>
+                <a:latin typeface="Yu Gothic"/>
               </a:defRPr>
             </a:pPr>
             <a:r>
-              <a:t>AI-integrated manual search acts as a 24/7 assistant, enabling junior operators to troubleshoot complex mechanical problems.</a:t>
+              <a:t>設備のダウンタイムを最小化し、保全業務のナレッジを組織的に共有・蓄積することで、工場稼働率の圧倒的向上を目指します。</a:t>
             </a:r>
           </a:p>
         </p:txBody>

</xml_diff>

<commit_message>
Restructure presentation to 8 slides aligned with script, add welding predictive maintenance, remove wire map
</commit_message>
<xml_diff>
--- a/seibi_presentation.pptx
+++ b/seibi_presentation.pptx
@@ -3150,7 +3150,7 @@
               </a:defRPr>
             </a:pPr>
             <a:r>
-              <a:t>設備管理システム — 設備点検アプリのご紹介</a:t>
+              <a:t>設備点検・不具合管理アプリのご紹介</a:t>
             </a:r>
           </a:p>
         </p:txBody>
@@ -3186,7 +3186,7 @@
               </a:defRPr>
             </a:pPr>
             <a:r>
-              <a:t>紙ベースの点検作業から、リアルタイム共有、AIによる現場修理サポートへ</a:t>
+              <a:t>点検業務のデジタル化から、リアルタイム状況共有、AI修理サポートまで</a:t>
             </a:r>
           </a:p>
           <a:p>
@@ -3202,7 +3202,7 @@
               </a:defRPr>
             </a:pPr>
             <a:r>
-              <a:t>Antigravity AI によってカスタマイズ</a:t>
+              <a:t>溶接チーム マーク</a:t>
             </a:r>
           </a:p>
         </p:txBody>
@@ -3264,7 +3264,7 @@
               </a:defRPr>
             </a:pPr>
             <a:r>
-              <a:t>1. 導入の経緯と従来の課題</a:t>
+              <a:t>1. 背景と課題</a:t>
             </a:r>
           </a:p>
         </p:txBody>
@@ -3303,7 +3303,7 @@
               </a:defRPr>
             </a:pPr>
             <a:r>
-              <a:t>❌ 履歴が残らない: 全て手書きの紙で点検を行い、提出後はファイル保管か処分するのみで検索できない。</a:t>
+              <a:t>❌ 点検履歴の散逸: 手書きの点検表は提出後にファイル保管されるか処分され、後から検索できるデジタル記録が残らない。</a:t>
             </a:r>
           </a:p>
           <a:p>
@@ -3319,23 +3319,7 @@
               </a:defRPr>
             </a:pPr>
             <a:r>
-              <a:t>❌ 過去の状況が不明: 過去の不具合や前月・去年の状況を確認する手段がなかった。</a:t>
-            </a:r>
-          </a:p>
-          <a:p>
-            <a:pPr>
-              <a:spcAft>
-                <a:spcPts val="1000"/>
-              </a:spcAft>
-              <a:defRPr sz="1400">
-                <a:solidFill>
-                  <a:srgbClr val="F3F4F6"/>
-                </a:solidFill>
-                <a:latin typeface="Yu Gothic"/>
-              </a:defRPr>
-            </a:pPr>
-            <a:r>
-              <a:t>❌ 状況のブラックボックス化: 点検表を持っている技術者本人以外には、設備の稼働・不具合状況が見えない。</a:t>
+              <a:t>❌ 過去の状況確認不可: 過去にどんな不具合があったのか、先月や昨年に設備に何が起きたのかを確認する方法がない。</a:t>
             </a:r>
           </a:p>
         </p:txBody>
@@ -3374,7 +3358,7 @@
               </a:defRPr>
             </a:pPr>
             <a:r>
-              <a:t>⚠️ 記憶頼みの点検: 同じ不具合が繰り返し起きていても、個人の記憶に頼らざるを得なかった。</a:t>
+              <a:t>⚠️ 繰り返す不具合の放置: 不具合が再発しても個人の記憶に頼るしかなく、不具合が修理されたかを追跡する仕組みもない。</a:t>
             </a:r>
           </a:p>
           <a:p>
@@ -3390,23 +3374,7 @@
               </a:defRPr>
             </a:pPr>
             <a:r>
-              <a:t>⚠️ 修理状況の追跡不可: 不具合を発見しても、実際に修理が完了したかを追跡する仕組みがない。</a:t>
-            </a:r>
-          </a:p>
-          <a:p>
-            <a:pPr>
-              <a:spcAft>
-                <a:spcPts val="1000"/>
-              </a:spcAft>
-              <a:defRPr sz="1400">
-                <a:solidFill>
-                  <a:srgbClr val="F3F4F6"/>
-                </a:solidFill>
-                <a:latin typeface="Yu Gothic"/>
-              </a:defRPr>
-            </a:pPr>
-            <a:r>
-              <a:t>⚠️ マニュアルの検索性悪化: 作業中に手順を確認する際、分厚い紙マニュアルをめくるか周りに聞くしかなかった。</a:t>
+              <a:t>⚠️ マニュアル参照の非効率: 修理中に手順を確認したい場合、分厚い紙マニュアルをめくるか周りに聞くしかない。</a:t>
             </a:r>
           </a:p>
         </p:txBody>
@@ -3468,7 +3436,7 @@
               </a:defRPr>
             </a:pPr>
             <a:r>
-              <a:t>2. 解決策 (1) 点検作業のデジタル化</a:t>
+              <a:t>2. 解決策 (1) 点検業務のデジタル化</a:t>
             </a:r>
           </a:p>
         </p:txBody>
@@ -3507,7 +3475,7 @@
               </a:defRPr>
             </a:pPr>
             <a:r>
-              <a:t>📱 モバイル端末での入力: タブレットやスマートフォンを使い、現場で即座に点検表を入力・提出可能。</a:t>
+              <a:t>📱 タブレットやスマホでの入力: 現場作業を行いながらその場から直接アプリに入力し提出可能。</a:t>
             </a:r>
           </a:p>
           <a:p>
@@ -3523,23 +3491,7 @@
               </a:defRPr>
             </a:pPr>
             <a:r>
-              <a:t>🔍 検索可能な履歴保存: 提出されたデータは自動蓄積され、過去の不具合履歴をいつでも検索・確認できるように。</a:t>
-            </a:r>
-          </a:p>
-          <a:p>
-            <a:pPr>
-              <a:spcAft>
-                <a:spcPts val="1000"/>
-              </a:spcAft>
-              <a:defRPr sz="1400">
-                <a:solidFill>
-                  <a:srgbClr val="F3F4F6"/>
-                </a:solidFill>
-                <a:latin typeface="Yu Gothic"/>
-              </a:defRPr>
-            </a:pPr>
-            <a:r>
-              <a:t>📊 稼働ダッシュボード: 今日のタスク進捗（例：0/13件完了）、異常発生件数、全体設備健全率を可視化。</a:t>
+              <a:t>🔒 データの安全な保存: 転記ミスや紛失を解消し、すべての点検結果は即座にデジタルデータとして安全に保存。</a:t>
             </a:r>
           </a:p>
         </p:txBody>
@@ -3625,7 +3577,7 @@
               </a:defRPr>
             </a:pPr>
             <a:r>
-              <a:t>2. 解決策 (2) 現場マップでの視覚的管理</a:t>
+              <a:t>2. 解決策 (1-追加) 検索可能な履歴ログ</a:t>
             </a:r>
           </a:p>
         </p:txBody>
@@ -3664,7 +3616,7 @@
               </a:defRPr>
             </a:pPr>
             <a:r>
-              <a:t>🗺️ インタラクティブ平面図: 工場内の溶接機やロボット、制御盤、ガスタンク等の配置を地図上で確認可能。</a:t>
+              <a:t>🔍 過去ログの動的検索: 過去の不具合履歴や点検結果を、日付や設備名から瞬時に呼び出せる検索機能を搭載。</a:t>
             </a:r>
           </a:p>
           <a:p>
@@ -3680,30 +3632,14 @@
               </a:defRPr>
             </a:pPr>
             <a:r>
-              <a:t>🔌 配線ルートの確認: 設備をタップするだけで、給電や通信の配線ルートをビジュアル表示。</a:t>
-            </a:r>
-          </a:p>
-          <a:p>
-            <a:pPr>
-              <a:spcAft>
-                <a:spcPts val="1000"/>
-              </a:spcAft>
-              <a:defRPr sz="1400">
-                <a:solidFill>
-                  <a:srgbClr val="F3F4F6"/>
-                </a:solidFill>
-                <a:latin typeface="Yu Gothic"/>
-              </a:defRPr>
-            </a:pPr>
-            <a:r>
-              <a:t>⚡ 直感的なトラブルシューティング: 異常が発生しているノードを素早く特定し、影響範囲を判断。</a:t>
+              <a:t>📈 不具合履歴の可視化: 設備ごとに不具合発生パターンを蓄積し、同じトラブルの再発傾向をデジタル上で一目で把握。</a:t>
             </a:r>
           </a:p>
         </p:txBody>
       </p:sp>
       <p:pic>
         <p:nvPicPr>
-          <p:cNvPr id="4" name="Picture 3" descr="app_wire_map.png"/>
+          <p:cNvPr id="4" name="Picture 3" descr="app_history.png"/>
           <p:cNvPicPr>
             <a:picLocks noChangeAspect="1"/>
           </p:cNvPicPr>
@@ -3782,7 +3718,7 @@
               </a:defRPr>
             </a:pPr>
             <a:r>
-              <a:t>2. 解決策 (3) 点検・修理履歴の監査ログ</a:t>
+              <a:t>2. 解決策 (2) 状況共有と管理</a:t>
             </a:r>
           </a:p>
         </p:txBody>
@@ -3821,7 +3757,7 @@
               </a:defRPr>
             </a:pPr>
             <a:r>
-              <a:t>📋 包括的な履歴ログ: 過去に実施した点検結果、不具合の内容、作業担当者をタイムスタンプ付きで記録。</a:t>
+              <a:t>⚙️ 自動タスク化: 点検表で「異常あり」と回答されると、システムが自動で修理タスクを作成し即座に登録。</a:t>
             </a:r>
           </a:p>
           <a:p>
@@ -3837,7 +3773,7 @@
               </a:defRPr>
             </a:pPr>
             <a:r>
-              <a:t>🔍 多彩なフィルタ機能: 日付順、設備順、期間（30日〜今年）やステータス（異常ありなど）で瞬時に絞り込み可能。</a:t>
+              <a:t>🚨 LINE WORKSへの自動アラート: 重大な不具合が検知された場合、LINE WORKSへ自動で緊急通知を送信。</a:t>
             </a:r>
           </a:p>
           <a:p>
@@ -3853,14 +3789,14 @@
               </a:defRPr>
             </a:pPr>
             <a:r>
-              <a:t>📈 修理進捗の追跡: 不具合に対する修理が完了しているかをデジタル上で管理し、対応漏れを防ぐ。</a:t>
+              <a:t>🔄 リアルタイム同期: 修理の状況や掲示板の内容が、すべてのデバイス（モバイル・PC）へリアルタイムに同期。</a:t>
             </a:r>
           </a:p>
         </p:txBody>
       </p:sp>
       <p:pic>
         <p:nvPicPr>
-          <p:cNvPr id="4" name="Picture 3" descr="app_history.png"/>
+          <p:cNvPr id="4" name="Picture 3" descr="app_bulletin.png"/>
           <p:cNvPicPr>
             <a:picLocks noChangeAspect="1"/>
           </p:cNvPicPr>
@@ -3939,7 +3875,7 @@
               </a:defRPr>
             </a:pPr>
             <a:r>
-              <a:t>2. 解決策 (4) リアルタイム状況共有・タスク化</a:t>
+              <a:t>2. 解決策 (3) AI修理サポート</a:t>
             </a:r>
           </a:p>
         </p:txBody>
@@ -3978,7 +3914,7 @@
               </a:defRPr>
             </a:pPr>
             <a:r>
-              <a:t>🚨 自動タスク登録 &amp; 通知: 不具合検知時、システムが自動的に修理タスクを作成し関係者に通知。</a:t>
+              <a:t>💬 自然言語でのスマート質問: 紙マニュアルをめくる代わりに、普段の言葉で質問可能（例：「ワイヤ送給がもたついている」）。</a:t>
             </a:r>
           </a:p>
           <a:p>
@@ -3994,7 +3930,7 @@
               </a:defRPr>
             </a:pPr>
             <a:r>
-              <a:t>💬 チャット・掲示板機能: 異常内容に対して、現場から「修理開始 (修理開始)」ボタンで即座に担当宣言が可能。</a:t>
+              <a:t>📖 引用元の提示: AIがマニュアルから関連箇所を読み取り、参照したページや項番を示しながら明確に回答。</a:t>
             </a:r>
           </a:p>
           <a:p>
@@ -4010,14 +3946,14 @@
               </a:defRPr>
             </a:pPr>
             <a:r>
-              <a:t>🔗 社内連絡ツールとの自動連携: 重大な不具合の場合は、社内チャットツールへ自動で警告通知を送信。</a:t>
+              <a:t>⚡ トラブル一次対応の迅速化: 直接先輩社員に聞いたり、電話をする手間を省き、その場で即時に一次対処が可能。</a:t>
             </a:r>
           </a:p>
         </p:txBody>
       </p:sp>
       <p:pic>
         <p:nvPicPr>
-          <p:cNvPr id="4" name="Picture 3" descr="app_bulletin.png"/>
+          <p:cNvPr id="4" name="Picture 3" descr="app_manuals.png"/>
           <p:cNvPicPr>
             <a:picLocks noChangeAspect="1"/>
           </p:cNvPicPr>
@@ -4096,7 +4032,7 @@
               </a:defRPr>
             </a:pPr>
             <a:r>
-              <a:t>2. 解決策 (5) AIによる現場修理サポート</a:t>
+              <a:t>3. 今後の展望 (1) データ主導</a:t>
             </a:r>
           </a:p>
         </p:txBody>
@@ -4110,7 +4046,7 @@
         <p:spPr>
           <a:xfrm>
             <a:off x="685800" y="1645920"/>
-            <a:ext cx="4114800" cy="4114800"/>
+            <a:ext cx="5029200" cy="4114800"/>
           </a:xfrm>
           <a:prstGeom prst="rect">
             <a:avLst/>
@@ -4135,7 +4071,7 @@
               </a:defRPr>
             </a:pPr>
             <a:r>
-              <a:t>🤖 自然言語での質問: 分厚いマニュアルをめくる代わりに、普段の言葉で質問可能（例：「J3関節で異音、ロボットアームが震えている」）。</a:t>
+              <a:t>📊 長期トレンドの統計分析: 蓄積された履歴を基に長期的な故障サイクルを分析し、最適なスケジュールメンテナンスを実現。</a:t>
             </a:r>
           </a:p>
           <a:p>
@@ -4151,7 +4087,7 @@
               </a:defRPr>
             </a:pPr>
             <a:r>
-              <a:t>📖 引用元の提示: AIが関連するマニュアル部分を特定し、「どの箇所の記述か」を示しながら的確に回答。</a:t>
+              <a:t>🔩 溶接機コンジットライナー詰まり予測: 点検記録からワイヤ送給のもたつきや滑り、アーク切れの予兆を特定。</a:t>
             </a:r>
           </a:p>
           <a:p>
@@ -4167,35 +4103,82 @@
               </a:defRPr>
             </a:pPr>
             <a:r>
-              <a:t>⚙️ カテゴリ別の構成: グラインダやCO2溶接ロボットなどのハードウェアごとに整理された手順書へ素早くアクセス。</a:t>
-            </a:r>
-          </a:p>
-        </p:txBody>
-      </p:sp>
-      <p:pic>
-        <p:nvPicPr>
-          <p:cNvPr id="4" name="Picture 3" descr="app_manuals.png"/>
-          <p:cNvPicPr>
-            <a:picLocks noChangeAspect="1"/>
-          </p:cNvPicPr>
+              <a:t>⚙️ ドライブロールの摩耗管理: 金属粉の蓄積やロール摩耗時期をデータで特定し、最適なタイミングで交換を実施してアーク停止を防止。</a:t>
+            </a:r>
+          </a:p>
+        </p:txBody>
+      </p:sp>
+      <p:sp>
+        <p:nvSpPr>
+          <p:cNvPr id="4" name="TextBox 3"/>
+          <p:cNvSpPr txBox="1"/>
           <p:nvPr/>
-        </p:nvPicPr>
-        <p:blipFill>
-          <a:blip r:embed="rId2"/>
-          <a:stretch>
-            <a:fillRect/>
-          </a:stretch>
-        </p:blipFill>
+        </p:nvSpPr>
         <p:spPr>
           <a:xfrm>
-            <a:off x="5120640" y="1463040"/>
-            <a:ext cx="6400800" cy="4000500"/>
+            <a:off x="6217920" y="1645920"/>
+            <a:ext cx="5029200" cy="4114800"/>
           </a:xfrm>
           <a:prstGeom prst="rect">
             <a:avLst/>
           </a:prstGeom>
+          <a:noFill/>
         </p:spPr>
-      </p:pic>
+        <p:txBody>
+          <a:bodyPr wrap="square">
+            <a:spAutoFit/>
+          </a:bodyPr>
+          <a:lstStyle/>
+          <a:p>
+            <a:pPr>
+              <a:spcAft>
+                <a:spcPts val="1000"/>
+              </a:spcAft>
+              <a:defRPr sz="1400" b="1">
+                <a:solidFill>
+                  <a:srgbClr val="F3F4F6"/>
+                </a:solidFill>
+                <a:latin typeface="Yu Gothic"/>
+              </a:defRPr>
+            </a:pPr>
+            <a:r>
+              <a:t>⚡ コンジットライナー金属粉量: 0.85g [警告値: 0.70g]</a:t>
+            </a:r>
+          </a:p>
+          <a:p>
+            <a:pPr>
+              <a:spcAft>
+                <a:spcPts val="1000"/>
+              </a:spcAft>
+              <a:defRPr sz="1400">
+                <a:solidFill>
+                  <a:srgbClr val="F3F4F6"/>
+                </a:solidFill>
+                <a:latin typeface="Yu Gothic"/>
+              </a:defRPr>
+            </a:pPr>
+            <a:r>
+              <a:t>⚠️ ワイヤ送給負荷 (トルク): 14.2 N·m [注意値: 12.0 N·m]</a:t>
+            </a:r>
+          </a:p>
+          <a:p>
+            <a:pPr>
+              <a:spcAft>
+                <a:spcPts val="1000"/>
+              </a:spcAft>
+              <a:defRPr sz="1400">
+                <a:solidFill>
+                  <a:srgbClr val="F3F4F6"/>
+                </a:solidFill>
+                <a:latin typeface="Yu Gothic"/>
+              </a:defRPr>
+            </a:pPr>
+            <a:r>
+              <a:t>🔧 推奨アクション: 次の段取り替え時にコンジットライナー交換を推奨 (予測限界まであと24稼働時間)</a:t>
+            </a:r>
+          </a:p>
+        </p:txBody>
+      </p:sp>
     </p:spTree>
   </p:cSld>
   <p:clrMapOvr>
@@ -4253,7 +4236,7 @@
               </a:defRPr>
             </a:pPr>
             <a:r>
-              <a:t>3. 成果と今後の展望</a:t>
+              <a:t>3. 今後の展望 (2 &amp; 3) AI機能の高度化</a:t>
             </a:r>
           </a:p>
         </p:txBody>
@@ -4292,23 +4275,7 @@
               </a:defRPr>
             </a:pPr>
             <a:r>
-              <a:t>開発はすべて完了し、現在は本格運用に向けた最終確認段階。</a:t>
-            </a:r>
-          </a:p>
-          <a:p>
-            <a:pPr>
-              <a:spcAft>
-                <a:spcPts val="1000"/>
-              </a:spcAft>
-              <a:defRPr sz="1400">
-                <a:solidFill>
-                  <a:srgbClr val="F3F4F6"/>
-                </a:solidFill>
-                <a:latin typeface="Yu Gothic"/>
-              </a:defRPr>
-            </a:pPr>
-            <a:r>
-              <a:t>紙廃止による履歴の蓄積、自動通知による迅速な初動、マニュアル検索時間のゼロ化による修理時間の大幅短縮を見込む。</a:t>
+              <a:t>一部の設備だけでなく、工場内のすべての主要設備の手順書・図面データをAIへ順次取り込み、サポート範囲を全域へ拡大。</a:t>
             </a:r>
           </a:p>
         </p:txBody>
@@ -4347,7 +4314,7 @@
               </a:defRPr>
             </a:pPr>
             <a:r>
-              <a:t>現在は一部の設備のみ対応しているマニュアルの範囲を広げ、工場内のすべての主要設備でAIサポートを利用可能に。</a:t>
+              <a:t>質問ログと「役に立ったか」の評価を記録。良質な回答を学習し、不要なものを除いて回答精度を高める仕組みを構築。</a:t>
             </a:r>
           </a:p>
         </p:txBody>
@@ -4361,7 +4328,7 @@
         <p:spPr>
           <a:xfrm>
             <a:off x="685800" y="3931920"/>
-            <a:ext cx="5029200" cy="2011680"/>
+            <a:ext cx="10820095" cy="1828800"/>
           </a:xfrm>
           <a:prstGeom prst="rect">
             <a:avLst/>
@@ -4386,62 +4353,7 @@
               </a:defRPr>
             </a:pPr>
             <a:r>
-              <a:t>技術者がAIにした質問と、その回答が役に立ったかどうかのフィードバックをログ化。</a:t>
-            </a:r>
-          </a:p>
-          <a:p>
-            <a:pPr>
-              <a:spcAft>
-                <a:spcPts val="1000"/>
-              </a:spcAft>
-              <a:defRPr sz="1400">
-                <a:solidFill>
-                  <a:srgbClr val="F3F4F6"/>
-                </a:solidFill>
-                <a:latin typeface="Yu Gothic"/>
-              </a:defRPr>
-            </a:pPr>
-            <a:r>
-              <a:t>有効な回答パターンを蓄積し、現場の利用実績に応じてAIの回答精度が自動で向上するエコシステムを構築。</a:t>
-            </a:r>
-          </a:p>
-        </p:txBody>
-      </p:sp>
-      <p:sp>
-        <p:nvSpPr>
-          <p:cNvPr id="6" name="TextBox 5"/>
-          <p:cNvSpPr txBox="1"/>
-          <p:nvPr/>
-        </p:nvSpPr>
-        <p:spPr>
-          <a:xfrm>
-            <a:off x="6217920" y="3931920"/>
-            <a:ext cx="5029200" cy="2011680"/>
-          </a:xfrm>
-          <a:prstGeom prst="rect">
-            <a:avLst/>
-          </a:prstGeom>
-          <a:noFill/>
-        </p:spPr>
-        <p:txBody>
-          <a:bodyPr wrap="square">
-            <a:spAutoFit/>
-          </a:bodyPr>
-          <a:lstStyle/>
-          <a:p>
-            <a:pPr>
-              <a:spcAft>
-                <a:spcPts val="1000"/>
-              </a:spcAft>
-              <a:defRPr sz="1400" b="1">
-                <a:solidFill>
-                  <a:srgbClr val="F3F4F6"/>
-                </a:solidFill>
-                <a:latin typeface="Yu Gothic"/>
-              </a:defRPr>
-            </a:pPr>
-            <a:r>
-              <a:t>設備のダウンタイムを最小化し、保全業務のナレッジを組織的に共有・蓄積することで、工場稼働率の圧倒的向上を目指します。</a:t>
+              <a:t>このアプリは単なる点検表のデジタル化ではありません。現場がより安全に働き、故障を防ぎ、設備を最高の状態で稼働させ続けるためのツールです。</a:t>
             </a:r>
           </a:p>
         </p:txBody>

</xml_diff>

<commit_message>
Update Slide 7 predictive maintenance metrics to be inspection log-based
</commit_message>
<xml_diff>
--- a/seibi_presentation.pptx
+++ b/seibi_presentation.pptx
@@ -4142,7 +4142,7 @@
               </a:defRPr>
             </a:pPr>
             <a:r>
-              <a:t>⚡ コンジットライナー金属粉量: 0.85g [警告値: 0.70g]</a:t>
+              <a:t>🔴 ワイヤ送給のもたつき: 3回検出 [警告基準: 2回以上]</a:t>
             </a:r>
           </a:p>
           <a:p>
@@ -4158,7 +4158,7 @@
               </a:defRPr>
             </a:pPr>
             <a:r>
-              <a:t>⚠️ ワイヤ送給負荷 (トルク): 14.2 N·m [注意値: 12.0 N·m]</a:t>
+              <a:t>🟡 ワイヤの滑り: 2回検出 [注意基準: 1回以上]</a:t>
             </a:r>
           </a:p>
           <a:p>
@@ -4174,7 +4174,23 @@
               </a:defRPr>
             </a:pPr>
             <a:r>
-              <a:t>🔧 推奨アクション: 次の段取り替え時にコンジットライナー交換を推奨 (予測限界まであと24稼働時間)</a:t>
+              <a:t>⚪ バーンバック (溶け上がり): 1回検出 [注意基準: 2回以上]</a:t>
+            </a:r>
+          </a:p>
+          <a:p>
+            <a:pPr>
+              <a:spcAft>
+                <a:spcPts val="1000"/>
+              </a:spcAft>
+              <a:defRPr sz="1400">
+                <a:solidFill>
+                  <a:srgbClr val="F3F4F6"/>
+                </a:solidFill>
+                <a:latin typeface="Yu Gothic"/>
+              </a:defRPr>
+            </a:pPr>
+            <a:r>
+              <a:t>🔧 推奨アクション: 点検記録より「もたつき」「滑り」の再発傾向を検知。金属粉による詰まりを防ぐため、次回の段取り替え時にライナー交換を推奨します。</a:t>
             </a:r>
           </a:p>
         </p:txBody>

</xml_diff>

<commit_message>
Update Slide 7 period to 5 months, remove burnback stat
</commit_message>
<xml_diff>
--- a/seibi_presentation.pptx
+++ b/seibi_presentation.pptx
@@ -4159,22 +4159,6 @@
             </a:pPr>
             <a:r>
               <a:t>🟡 ワイヤの滑り: 2回検出 [注意基準: 1回以上]</a:t>
-            </a:r>
-          </a:p>
-          <a:p>
-            <a:pPr>
-              <a:spcAft>
-                <a:spcPts val="1000"/>
-              </a:spcAft>
-              <a:defRPr sz="1400">
-                <a:solidFill>
-                  <a:srgbClr val="F3F4F6"/>
-                </a:solidFill>
-                <a:latin typeface="Yu Gothic"/>
-              </a:defRPr>
-            </a:pPr>
-            <a:r>
-              <a:t>⚪ バーンバック (溶け上がり): 1回検出 [注意基準: 2回以上]</a:t>
             </a:r>
           </a:p>
           <a:p>

</xml_diff>

<commit_message>
Restructure presentation to 10 slides: add separator slides, remove slide numbering
</commit_message>
<xml_diff>
--- a/seibi_presentation.pptx
+++ b/seibi_presentation.pptx
@@ -13,6 +13,8 @@
     <p:sldId id="261" r:id="rId12"/>
     <p:sldId id="262" r:id="rId13"/>
     <p:sldId id="263" r:id="rId14"/>
+    <p:sldId id="264" r:id="rId15"/>
+    <p:sldId id="265" r:id="rId16"/>
   </p:sldIdLst>
   <p:sldSz cx="12191695" cy="6858000" type="screen4x3"/>
   <p:notesSz cx="6858000" cy="9144000"/>
@@ -3215,6 +3217,185 @@
 </p:sld>
 </file>
 
+<file path=ppt/slides/slide10.xml><?xml version="1.0" encoding="utf-8"?>
+<p:sld xmlns:a="http://schemas.openxmlformats.org/drawingml/2006/main" xmlns:p="http://schemas.openxmlformats.org/presentationml/2006/main" xmlns:r="http://schemas.openxmlformats.org/officeDocument/2006/relationships">
+  <p:cSld>
+    <p:bg>
+      <p:bgPr>
+        <a:solidFill>
+          <a:srgbClr val="0B0E14"/>
+        </a:solidFill>
+        <a:effectLst/>
+      </p:bgPr>
+    </p:bg>
+    <p:spTree>
+      <p:nvGrpSpPr>
+        <p:cNvPr id="1" name=""/>
+        <p:cNvGrpSpPr/>
+        <p:nvPr/>
+      </p:nvGrpSpPr>
+      <p:grpSpPr/>
+      <p:sp>
+        <p:nvSpPr>
+          <p:cNvPr id="2" name="TextBox 1"/>
+          <p:cNvSpPr txBox="1"/>
+          <p:nvPr/>
+        </p:nvSpPr>
+        <p:spPr>
+          <a:xfrm>
+            <a:off x="685800" y="457200"/>
+            <a:ext cx="10820095" cy="731520"/>
+          </a:xfrm>
+          <a:prstGeom prst="rect">
+            <a:avLst/>
+          </a:prstGeom>
+          <a:noFill/>
+        </p:spPr>
+        <p:txBody>
+          <a:bodyPr wrap="square">
+            <a:spAutoFit/>
+          </a:bodyPr>
+          <a:lstStyle/>
+          <a:p>
+            <a:pPr>
+              <a:defRPr sz="2800" b="1">
+                <a:solidFill>
+                  <a:srgbClr val="3B82F6"/>
+                </a:solidFill>
+                <a:latin typeface="Yu Gothic"/>
+              </a:defRPr>
+            </a:pPr>
+            <a:r>
+              <a:t>今後の展望：AI機能の高度化</a:t>
+            </a:r>
+          </a:p>
+        </p:txBody>
+      </p:sp>
+      <p:sp>
+        <p:nvSpPr>
+          <p:cNvPr id="3" name="TextBox 2"/>
+          <p:cNvSpPr txBox="1"/>
+          <p:nvPr/>
+        </p:nvSpPr>
+        <p:spPr>
+          <a:xfrm>
+            <a:off x="685800" y="1645920"/>
+            <a:ext cx="5029200" cy="2011680"/>
+          </a:xfrm>
+          <a:prstGeom prst="rect">
+            <a:avLst/>
+          </a:prstGeom>
+          <a:noFill/>
+        </p:spPr>
+        <p:txBody>
+          <a:bodyPr wrap="square">
+            <a:spAutoFit/>
+          </a:bodyPr>
+          <a:lstStyle/>
+          <a:p>
+            <a:pPr>
+              <a:spcAft>
+                <a:spcPts val="1000"/>
+              </a:spcAft>
+              <a:defRPr sz="1400" b="1">
+                <a:solidFill>
+                  <a:srgbClr val="F3F4F6"/>
+                </a:solidFill>
+                <a:latin typeface="Yu Gothic"/>
+              </a:defRPr>
+            </a:pPr>
+            <a:r>
+              <a:t>一部の設備だけでなく、工場内のすべての主要設備の手順書・図面データをAIへ順次取り込み、サポート範囲を全域へ拡大。</a:t>
+            </a:r>
+          </a:p>
+        </p:txBody>
+      </p:sp>
+      <p:sp>
+        <p:nvSpPr>
+          <p:cNvPr id="4" name="TextBox 3"/>
+          <p:cNvSpPr txBox="1"/>
+          <p:nvPr/>
+        </p:nvSpPr>
+        <p:spPr>
+          <a:xfrm>
+            <a:off x="6217920" y="1645920"/>
+            <a:ext cx="5029200" cy="2011680"/>
+          </a:xfrm>
+          <a:prstGeom prst="rect">
+            <a:avLst/>
+          </a:prstGeom>
+          <a:noFill/>
+        </p:spPr>
+        <p:txBody>
+          <a:bodyPr wrap="square">
+            <a:spAutoFit/>
+          </a:bodyPr>
+          <a:lstStyle/>
+          <a:p>
+            <a:pPr>
+              <a:spcAft>
+                <a:spcPts val="1000"/>
+              </a:spcAft>
+              <a:defRPr sz="1400" b="1">
+                <a:solidFill>
+                  <a:srgbClr val="F3F4F6"/>
+                </a:solidFill>
+                <a:latin typeface="Yu Gothic"/>
+              </a:defRPr>
+            </a:pPr>
+            <a:r>
+              <a:t>質問ログと「役に立ったか」の評価を記録。良質な回答を学習し、不要なものを除いて回答精度を高める仕組みを構築。</a:t>
+            </a:r>
+          </a:p>
+        </p:txBody>
+      </p:sp>
+      <p:sp>
+        <p:nvSpPr>
+          <p:cNvPr id="5" name="TextBox 4"/>
+          <p:cNvSpPr txBox="1"/>
+          <p:nvPr/>
+        </p:nvSpPr>
+        <p:spPr>
+          <a:xfrm>
+            <a:off x="685800" y="3931920"/>
+            <a:ext cx="10820095" cy="1828800"/>
+          </a:xfrm>
+          <a:prstGeom prst="rect">
+            <a:avLst/>
+          </a:prstGeom>
+          <a:noFill/>
+        </p:spPr>
+        <p:txBody>
+          <a:bodyPr wrap="square">
+            <a:spAutoFit/>
+          </a:bodyPr>
+          <a:lstStyle/>
+          <a:p>
+            <a:pPr>
+              <a:spcAft>
+                <a:spcPts val="1000"/>
+              </a:spcAft>
+              <a:defRPr sz="1400" b="1">
+                <a:solidFill>
+                  <a:srgbClr val="F3F4F6"/>
+                </a:solidFill>
+                <a:latin typeface="Yu Gothic"/>
+              </a:defRPr>
+            </a:pPr>
+            <a:r>
+              <a:t>このアプリは単なる点検表のデジタル化ではありません。現場がより安全に働き、故障を防ぎ、設備を最高の状態で稼働させ続けるためのツールです。</a:t>
+            </a:r>
+          </a:p>
+        </p:txBody>
+      </p:sp>
+    </p:spTree>
+  </p:cSld>
+  <p:clrMapOvr>
+    <a:masterClrMapping/>
+  </p:clrMapOvr>
+</p:sld>
+</file>
+
 <file path=ppt/slides/slide2.xml><?xml version="1.0" encoding="utf-8"?>
 <p:sld xmlns:a="http://schemas.openxmlformats.org/drawingml/2006/main" xmlns:p="http://schemas.openxmlformats.org/presentationml/2006/main" xmlns:r="http://schemas.openxmlformats.org/officeDocument/2006/relationships">
   <p:cSld>
@@ -3264,7 +3445,7 @@
               </a:defRPr>
             </a:pPr>
             <a:r>
-              <a:t>1. 背景と課題</a:t>
+              <a:t>背景と課題</a:t>
             </a:r>
           </a:p>
         </p:txBody>
@@ -3358,7 +3539,7 @@
               </a:defRPr>
             </a:pPr>
             <a:r>
-              <a:t>⚠️ 繰り返す不具合の放置: 不具合が再発しても個人の記憶に頼るしかなく、不具合が修理されたかを追跡する仕組みもない。</a:t>
+              <a:t>⚠️ 繰り返す不具合の放置: 不具合が再発しても個人の記憶に頼るしかなく、不具合が実際に修理されたかを追跡する仕組みもない。</a:t>
             </a:r>
           </a:p>
           <a:p>
@@ -3413,8 +3594,8 @@
         </p:nvSpPr>
         <p:spPr>
           <a:xfrm>
-            <a:off x="685800" y="457200"/>
-            <a:ext cx="10820095" cy="731520"/>
+            <a:off x="685800" y="1371600"/>
+            <a:ext cx="10820095" cy="1371600"/>
           </a:xfrm>
           <a:prstGeom prst="rect">
             <a:avLst/>
@@ -3428,7 +3609,7 @@
           <a:lstStyle/>
           <a:p>
             <a:pPr>
-              <a:defRPr sz="2800" b="1">
+              <a:defRPr sz="4400" b="1">
                 <a:solidFill>
                   <a:srgbClr val="3B82F6"/>
                 </a:solidFill>
@@ -3436,7 +3617,7 @@
               </a:defRPr>
             </a:pPr>
             <a:r>
-              <a:t>2. 解決策 (1) 点検業務のデジタル化</a:t>
+              <a:t>解決策と取り組み</a:t>
             </a:r>
           </a:p>
         </p:txBody>
@@ -3449,8 +3630,8 @@
         </p:nvSpPr>
         <p:spPr>
           <a:xfrm>
-            <a:off x="685800" y="1645920"/>
-            <a:ext cx="4114800" cy="4114800"/>
+            <a:off x="685800" y="2926080"/>
+            <a:ext cx="10820095" cy="2743200"/>
           </a:xfrm>
           <a:prstGeom prst="rect">
             <a:avLst/>
@@ -3465,9 +3646,9 @@
           <a:p>
             <a:pPr>
               <a:spcAft>
-                <a:spcPts val="1000"/>
+                <a:spcPts val="2000"/>
               </a:spcAft>
-              <a:defRPr sz="1400" b="1">
+              <a:defRPr sz="2200" b="1">
                 <a:solidFill>
                   <a:srgbClr val="F3F4F6"/>
                 </a:solidFill>
@@ -3475,15 +3656,15 @@
               </a:defRPr>
             </a:pPr>
             <a:r>
-              <a:t>📱 タブレットやスマホでの入力: 現場作業を行いながらその場から直接アプリに入力し提出可能。</a:t>
+              <a:t>1. 点検業務のデジタル化</a:t>
             </a:r>
           </a:p>
           <a:p>
             <a:pPr>
               <a:spcAft>
-                <a:spcPts val="1000"/>
+                <a:spcPts val="2000"/>
               </a:spcAft>
-              <a:defRPr sz="1400">
+              <a:defRPr sz="2200" b="1">
                 <a:solidFill>
                   <a:srgbClr val="F3F4F6"/>
                 </a:solidFill>
@@ -3491,35 +3672,27 @@
               </a:defRPr>
             </a:pPr>
             <a:r>
-              <a:t>🔒 データの安全な保存: 転記ミスや紛失を解消し、すべての点検結果は即座にデジタルデータとして安全に保存。</a:t>
-            </a:r>
-          </a:p>
-        </p:txBody>
-      </p:sp>
-      <p:pic>
-        <p:nvPicPr>
-          <p:cNvPr id="4" name="Picture 3" descr="app_dashboard.png"/>
-          <p:cNvPicPr>
-            <a:picLocks noChangeAspect="1"/>
-          </p:cNvPicPr>
-          <p:nvPr/>
-        </p:nvPicPr>
-        <p:blipFill>
-          <a:blip r:embed="rId2"/>
-          <a:stretch>
-            <a:fillRect/>
-          </a:stretch>
-        </p:blipFill>
-        <p:spPr>
-          <a:xfrm>
-            <a:off x="5120640" y="1463040"/>
-            <a:ext cx="6400800" cy="4000500"/>
-          </a:xfrm>
-          <a:prstGeom prst="rect">
-            <a:avLst/>
-          </a:prstGeom>
-        </p:spPr>
-      </p:pic>
+              <a:t>2. リアルタイムの状況共有と管理</a:t>
+            </a:r>
+          </a:p>
+          <a:p>
+            <a:pPr>
+              <a:spcAft>
+                <a:spcPts val="2000"/>
+              </a:spcAft>
+              <a:defRPr sz="2200" b="1">
+                <a:solidFill>
+                  <a:srgbClr val="F3F4F6"/>
+                </a:solidFill>
+                <a:latin typeface="Yu Gothic"/>
+              </a:defRPr>
+            </a:pPr>
+            <a:r>
+              <a:t>3. AI搭載の修理サポート機能</a:t>
+            </a:r>
+          </a:p>
+        </p:txBody>
+      </p:sp>
     </p:spTree>
   </p:cSld>
   <p:clrMapOvr>
@@ -3577,7 +3750,7 @@
               </a:defRPr>
             </a:pPr>
             <a:r>
-              <a:t>2. 解決策 (1-追加) 検索可能な履歴ログ</a:t>
+              <a:t>解決策：点検業務のデジタル化</a:t>
             </a:r>
           </a:p>
         </p:txBody>
@@ -3616,7 +3789,7 @@
               </a:defRPr>
             </a:pPr>
             <a:r>
-              <a:t>🔍 過去ログの動的検索: 過去の不具合履歴や点検結果を、日付や設備名から瞬時に呼び出せる検索機能を搭載。</a:t>
+              <a:t>📱 タブレットやスマホでの入力: 現場作業を行いながらその場から直接アプリに入力し提出可能。</a:t>
             </a:r>
           </a:p>
           <a:p>
@@ -3632,14 +3805,14 @@
               </a:defRPr>
             </a:pPr>
             <a:r>
-              <a:t>📈 不具合履歴の可視化: 設備ごとに不具合発生パターンを蓄積し、同じトラブルの再発傾向をデジタル上で一目で把握。</a:t>
+              <a:t>🔒 データの安全な保存: 転記ミスや紛失を解消し、すべての点検結果は即座にデジタルデータとして安全に保存。</a:t>
             </a:r>
           </a:p>
         </p:txBody>
       </p:sp>
       <p:pic>
         <p:nvPicPr>
-          <p:cNvPr id="4" name="Picture 3" descr="app_history.png"/>
+          <p:cNvPr id="4" name="Picture 3" descr="app_dashboard.png"/>
           <p:cNvPicPr>
             <a:picLocks noChangeAspect="1"/>
           </p:cNvPicPr>
@@ -3718,7 +3891,7 @@
               </a:defRPr>
             </a:pPr>
             <a:r>
-              <a:t>2. 解決策 (2) 状況共有と管理</a:t>
+              <a:t>解決策：検索可能な履歴ログ</a:t>
             </a:r>
           </a:p>
         </p:txBody>
@@ -3757,7 +3930,7 @@
               </a:defRPr>
             </a:pPr>
             <a:r>
-              <a:t>⚙️ 自動タスク化: 点検表で「異常あり」と回答されると、システムが自動で修理タスクを作成し即座に登録。</a:t>
+              <a:t>🔍 過去ログの動的検索: 過去の不具合履歴や点検結果を、日付や設備名から瞬時に呼び出せる検索機能を搭載。</a:t>
             </a:r>
           </a:p>
           <a:p>
@@ -3773,30 +3946,14 @@
               </a:defRPr>
             </a:pPr>
             <a:r>
-              <a:t>🚨 LINE WORKSへの自動アラート: 重大な不具合が検知された場合、LINE WORKSへ自動で緊急通知を送信。</a:t>
-            </a:r>
-          </a:p>
-          <a:p>
-            <a:pPr>
-              <a:spcAft>
-                <a:spcPts val="1000"/>
-              </a:spcAft>
-              <a:defRPr sz="1400">
-                <a:solidFill>
-                  <a:srgbClr val="F3F4F6"/>
-                </a:solidFill>
-                <a:latin typeface="Yu Gothic"/>
-              </a:defRPr>
-            </a:pPr>
-            <a:r>
-              <a:t>🔄 リアルタイム同期: 修理の状況や掲示板の内容が、すべてのデバイス（モバイル・PC）へリアルタイムに同期。</a:t>
+              <a:t>📈 不具合履歴の可視化: 設備ごとに不具合発生パターンを蓄積し、同じトラブルの再発傾向をデジタル上で一目で把握。</a:t>
             </a:r>
           </a:p>
         </p:txBody>
       </p:sp>
       <p:pic>
         <p:nvPicPr>
-          <p:cNvPr id="4" name="Picture 3" descr="app_bulletin.png"/>
+          <p:cNvPr id="4" name="Picture 3" descr="app_history.png"/>
           <p:cNvPicPr>
             <a:picLocks noChangeAspect="1"/>
           </p:cNvPicPr>
@@ -3875,7 +4032,7 @@
               </a:defRPr>
             </a:pPr>
             <a:r>
-              <a:t>2. 解決策 (3) AI修理サポート</a:t>
+              <a:t>解決策：状況共有と管理</a:t>
             </a:r>
           </a:p>
         </p:txBody>
@@ -3914,7 +4071,7 @@
               </a:defRPr>
             </a:pPr>
             <a:r>
-              <a:t>💬 自然言語でのスマート質問: 紙マニュアルをめくる代わりに、普段の言葉で質問可能（例：「ワイヤ送給がもたついている」）。</a:t>
+              <a:t>⚙️ 自動タスク化: 点検表で「異常あり」と回答されると、システムが自動で修理タスクを作成し即座に登録。</a:t>
             </a:r>
           </a:p>
           <a:p>
@@ -3930,7 +4087,7 @@
               </a:defRPr>
             </a:pPr>
             <a:r>
-              <a:t>📖 引用元の提示: AIがマニュアルから関連箇所を読み取り、参照したページや項番を示しながら明確に回答。</a:t>
+              <a:t>🚨 LINE WORKSへの自動アラート: 重大な不具合が検知された場合、LINE WORKSへ自動で緊急通知を送信。</a:t>
             </a:r>
           </a:p>
           <a:p>
@@ -3946,14 +4103,14 @@
               </a:defRPr>
             </a:pPr>
             <a:r>
-              <a:t>⚡ トラブル一次対応の迅速化: 直接先輩社員に聞いたり、電話をする手間を省き、その場で即時に一次対処が可能。</a:t>
+              <a:t>🔄 リアルタイム同期: 修理の状況や掲示板の内容が、すべてのデバイス（モバイル・PC）へリアルタイムに同期。</a:t>
             </a:r>
           </a:p>
         </p:txBody>
       </p:sp>
       <p:pic>
         <p:nvPicPr>
-          <p:cNvPr id="4" name="Picture 3" descr="app_manuals.png"/>
+          <p:cNvPr id="4" name="Picture 3" descr="app_bulletin.png"/>
           <p:cNvPicPr>
             <a:picLocks noChangeAspect="1"/>
           </p:cNvPicPr>
@@ -4032,7 +4189,7 @@
               </a:defRPr>
             </a:pPr>
             <a:r>
-              <a:t>3. 今後の展望 (1) データ主導</a:t>
+              <a:t>解決策：AI修理サポート</a:t>
             </a:r>
           </a:p>
         </p:txBody>
@@ -4046,7 +4203,7 @@
         <p:spPr>
           <a:xfrm>
             <a:off x="685800" y="1645920"/>
-            <a:ext cx="5029200" cy="4114800"/>
+            <a:ext cx="4114800" cy="4114800"/>
           </a:xfrm>
           <a:prstGeom prst="rect">
             <a:avLst/>
@@ -4071,7 +4228,7 @@
               </a:defRPr>
             </a:pPr>
             <a:r>
-              <a:t>📊 長期トレンドの統計分析: 蓄積された履歴を基に長期的な故障サイクルを分析し、最適なスケジュールメンテナンスを実現。</a:t>
+              <a:t>💬 自然言語でのスマート質問: 紙マニュアルをめくる代わりに、普段の言葉で質問可能（例：「ワイヤ送給がもたついている」）。</a:t>
             </a:r>
           </a:p>
           <a:p>
@@ -4087,7 +4244,7 @@
               </a:defRPr>
             </a:pPr>
             <a:r>
-              <a:t>🔩 溶接機コンジットライナー詰まり予測: 点検記録からワイヤ送給のもたつきや滑り、アーク切れの予兆を特定。</a:t>
+              <a:t>📖 引用元の提示: AIがマニュアルから関連箇所を読み取り、参照したページや項番を示しながら明確な回答。</a:t>
             </a:r>
           </a:p>
           <a:p>
@@ -4103,82 +4260,35 @@
               </a:defRPr>
             </a:pPr>
             <a:r>
-              <a:t>⚙️ ドライブロールの摩耗管理: 金属粉の蓄積やロール摩耗時期をデータで特定し、最適なタイミングで交換を実施してアーク停止を防止。</a:t>
-            </a:r>
-          </a:p>
-        </p:txBody>
-      </p:sp>
-      <p:sp>
-        <p:nvSpPr>
-          <p:cNvPr id="4" name="TextBox 3"/>
-          <p:cNvSpPr txBox="1"/>
+              <a:t>⚡ トラブル一次対応の迅速化: 直接先輩社員に聞いたり、電話をする手間を省き、その場で即時に一次対処が可能。</a:t>
+            </a:r>
+          </a:p>
+        </p:txBody>
+      </p:sp>
+      <p:pic>
+        <p:nvPicPr>
+          <p:cNvPr id="4" name="Picture 3" descr="app_manuals.png"/>
+          <p:cNvPicPr>
+            <a:picLocks noChangeAspect="1"/>
+          </p:cNvPicPr>
           <p:nvPr/>
-        </p:nvSpPr>
-        <p:spPr>
-          <a:xfrm>
-            <a:off x="6217920" y="1645920"/>
-            <a:ext cx="5029200" cy="4114800"/>
+        </p:nvPicPr>
+        <p:blipFill>
+          <a:blip r:embed="rId2"/>
+          <a:stretch>
+            <a:fillRect/>
+          </a:stretch>
+        </p:blipFill>
+        <p:spPr>
+          <a:xfrm>
+            <a:off x="5120640" y="1463040"/>
+            <a:ext cx="6400800" cy="4000500"/>
           </a:xfrm>
           <a:prstGeom prst="rect">
             <a:avLst/>
           </a:prstGeom>
-          <a:noFill/>
-        </p:spPr>
-        <p:txBody>
-          <a:bodyPr wrap="square">
-            <a:spAutoFit/>
-          </a:bodyPr>
-          <a:lstStyle/>
-          <a:p>
-            <a:pPr>
-              <a:spcAft>
-                <a:spcPts val="1000"/>
-              </a:spcAft>
-              <a:defRPr sz="1400" b="1">
-                <a:solidFill>
-                  <a:srgbClr val="F3F4F6"/>
-                </a:solidFill>
-                <a:latin typeface="Yu Gothic"/>
-              </a:defRPr>
-            </a:pPr>
-            <a:r>
-              <a:t>🔴 ワイヤ送給のもたつき: 3回検出 [警告基準: 2回以上]</a:t>
-            </a:r>
-          </a:p>
-          <a:p>
-            <a:pPr>
-              <a:spcAft>
-                <a:spcPts val="1000"/>
-              </a:spcAft>
-              <a:defRPr sz="1400">
-                <a:solidFill>
-                  <a:srgbClr val="F3F4F6"/>
-                </a:solidFill>
-                <a:latin typeface="Yu Gothic"/>
-              </a:defRPr>
-            </a:pPr>
-            <a:r>
-              <a:t>🟡 ワイヤの滑り: 2回検出 [注意基準: 1回以上]</a:t>
-            </a:r>
-          </a:p>
-          <a:p>
-            <a:pPr>
-              <a:spcAft>
-                <a:spcPts val="1000"/>
-              </a:spcAft>
-              <a:defRPr sz="1400">
-                <a:solidFill>
-                  <a:srgbClr val="F3F4F6"/>
-                </a:solidFill>
-                <a:latin typeface="Yu Gothic"/>
-              </a:defRPr>
-            </a:pPr>
-            <a:r>
-              <a:t>🔧 推奨アクション: 点検記録より「もたつき」「滑り」の再発傾向を検知。金属粉による詰まりを防ぐため、次回の段取り替え時にライナー交換を推奨します。</a:t>
-            </a:r>
-          </a:p>
-        </p:txBody>
-      </p:sp>
+        </p:spPr>
+      </p:pic>
     </p:spTree>
   </p:cSld>
   <p:clrMapOvr>
@@ -4213,8 +4323,8 @@
         </p:nvSpPr>
         <p:spPr>
           <a:xfrm>
-            <a:off x="685800" y="457200"/>
-            <a:ext cx="10820095" cy="731520"/>
+            <a:off x="685800" y="1371600"/>
+            <a:ext cx="10820095" cy="1371600"/>
           </a:xfrm>
           <a:prstGeom prst="rect">
             <a:avLst/>
@@ -4228,7 +4338,7 @@
           <a:lstStyle/>
           <a:p>
             <a:pPr>
-              <a:defRPr sz="2800" b="1">
+              <a:defRPr sz="4400" b="1">
                 <a:solidFill>
                   <a:srgbClr val="3B82F6"/>
                 </a:solidFill>
@@ -4236,7 +4346,7 @@
               </a:defRPr>
             </a:pPr>
             <a:r>
-              <a:t>3. 今後の展望 (2 &amp; 3) AI機能の高度化</a:t>
+              <a:t>成果と今後の展望</a:t>
             </a:r>
           </a:p>
         </p:txBody>
@@ -4249,8 +4359,141 @@
         </p:nvSpPr>
         <p:spPr>
           <a:xfrm>
+            <a:off x="685800" y="2926080"/>
+            <a:ext cx="10820095" cy="2743200"/>
+          </a:xfrm>
+          <a:prstGeom prst="rect">
+            <a:avLst/>
+          </a:prstGeom>
+          <a:noFill/>
+        </p:spPr>
+        <p:txBody>
+          <a:bodyPr wrap="square">
+            <a:spAutoFit/>
+          </a:bodyPr>
+          <a:lstStyle/>
+          <a:p>
+            <a:pPr>
+              <a:spcAft>
+                <a:spcPts val="2000"/>
+              </a:spcAft>
+              <a:defRPr sz="2200" b="1">
+                <a:solidFill>
+                  <a:srgbClr val="F3F4F6"/>
+                </a:solidFill>
+                <a:latin typeface="Yu Gothic"/>
+              </a:defRPr>
+            </a:pPr>
+            <a:r>
+              <a:t>1. データ主導のメンテナンス</a:t>
+            </a:r>
+          </a:p>
+          <a:p>
+            <a:pPr>
+              <a:spcAft>
+                <a:spcPts val="2000"/>
+              </a:spcAft>
+              <a:defRPr sz="2200" b="1">
+                <a:solidFill>
+                  <a:srgbClr val="F3F4F6"/>
+                </a:solidFill>
+                <a:latin typeface="Yu Gothic"/>
+              </a:defRPr>
+            </a:pPr>
+            <a:r>
+              <a:t>2. AI対応マニュアルの拡大</a:t>
+            </a:r>
+          </a:p>
+          <a:p>
+            <a:pPr>
+              <a:spcAft>
+                <a:spcPts val="2000"/>
+              </a:spcAft>
+              <a:defRPr sz="2200" b="1">
+                <a:solidFill>
+                  <a:srgbClr val="F3F4F6"/>
+                </a:solidFill>
+                <a:latin typeface="Yu Gothic"/>
+              </a:defRPr>
+            </a:pPr>
+            <a:r>
+              <a:t>3. 使うほど賢くなるAI学習ループ</a:t>
+            </a:r>
+          </a:p>
+        </p:txBody>
+      </p:sp>
+    </p:spTree>
+  </p:cSld>
+  <p:clrMapOvr>
+    <a:masterClrMapping/>
+  </p:clrMapOvr>
+</p:sld>
+</file>
+
+<file path=ppt/slides/slide9.xml><?xml version="1.0" encoding="utf-8"?>
+<p:sld xmlns:a="http://schemas.openxmlformats.org/drawingml/2006/main" xmlns:p="http://schemas.openxmlformats.org/presentationml/2006/main" xmlns:r="http://schemas.openxmlformats.org/officeDocument/2006/relationships">
+  <p:cSld>
+    <p:bg>
+      <p:bgPr>
+        <a:solidFill>
+          <a:srgbClr val="0B0E14"/>
+        </a:solidFill>
+        <a:effectLst/>
+      </p:bgPr>
+    </p:bg>
+    <p:spTree>
+      <p:nvGrpSpPr>
+        <p:cNvPr id="1" name=""/>
+        <p:cNvGrpSpPr/>
+        <p:nvPr/>
+      </p:nvGrpSpPr>
+      <p:grpSpPr/>
+      <p:sp>
+        <p:nvSpPr>
+          <p:cNvPr id="2" name="TextBox 1"/>
+          <p:cNvSpPr txBox="1"/>
+          <p:nvPr/>
+        </p:nvSpPr>
+        <p:spPr>
+          <a:xfrm>
+            <a:off x="685800" y="457200"/>
+            <a:ext cx="10820095" cy="731520"/>
+          </a:xfrm>
+          <a:prstGeom prst="rect">
+            <a:avLst/>
+          </a:prstGeom>
+          <a:noFill/>
+        </p:spPr>
+        <p:txBody>
+          <a:bodyPr wrap="square">
+            <a:spAutoFit/>
+          </a:bodyPr>
+          <a:lstStyle/>
+          <a:p>
+            <a:pPr>
+              <a:defRPr sz="2800" b="1">
+                <a:solidFill>
+                  <a:srgbClr val="3B82F6"/>
+                </a:solidFill>
+                <a:latin typeface="Yu Gothic"/>
+              </a:defRPr>
+            </a:pPr>
+            <a:r>
+              <a:t>今後の展望：データ主導の保全</a:t>
+            </a:r>
+          </a:p>
+        </p:txBody>
+      </p:sp>
+      <p:sp>
+        <p:nvSpPr>
+          <p:cNvPr id="3" name="TextBox 2"/>
+          <p:cNvSpPr txBox="1"/>
+          <p:nvPr/>
+        </p:nvSpPr>
+        <p:spPr>
+          <a:xfrm>
             <a:off x="685800" y="1645920"/>
-            <a:ext cx="5029200" cy="2011680"/>
+            <a:ext cx="5029200" cy="4114800"/>
           </a:xfrm>
           <a:prstGeom prst="rect">
             <a:avLst/>
@@ -4275,7 +4518,39 @@
               </a:defRPr>
             </a:pPr>
             <a:r>
-              <a:t>一部の設備だけでなく、工場内のすべての主要設備の手順書・図面データをAIへ順次取り込み、サポート範囲を全域へ拡大。</a:t>
+              <a:t>📊 長期トレンドの統計分析: 蓄積された履歴を基に長期的な故障サイクルを分析し、最適なスケジュールメンテナンスを実現。</a:t>
+            </a:r>
+          </a:p>
+          <a:p>
+            <a:pPr>
+              <a:spcAft>
+                <a:spcPts val="1000"/>
+              </a:spcAft>
+              <a:defRPr sz="1400">
+                <a:solidFill>
+                  <a:srgbClr val="F3F4F6"/>
+                </a:solidFill>
+                <a:latin typeface="Yu Gothic"/>
+              </a:defRPr>
+            </a:pPr>
+            <a:r>
+              <a:t>🔩 溶接機コンジットライナー詰まり予測: 点検記録からワイヤ送給のもたつきや滑り、アーク切れの予兆を特定。</a:t>
+            </a:r>
+          </a:p>
+          <a:p>
+            <a:pPr>
+              <a:spcAft>
+                <a:spcPts val="1000"/>
+              </a:spcAft>
+              <a:defRPr sz="1400">
+                <a:solidFill>
+                  <a:srgbClr val="F3F4F6"/>
+                </a:solidFill>
+                <a:latin typeface="Yu Gothic"/>
+              </a:defRPr>
+            </a:pPr>
+            <a:r>
+              <a:t>⚙️ ドライブロールの摩耗管理: 金属粉の蓄積やロール摩耗時期をデータで特定し、最適なタイミングで交換を実施してアーク停止を防止。</a:t>
             </a:r>
           </a:p>
         </p:txBody>
@@ -4289,7 +4564,7 @@
         <p:spPr>
           <a:xfrm>
             <a:off x="6217920" y="1645920"/>
-            <a:ext cx="5029200" cy="2011680"/>
+            <a:ext cx="5029200" cy="4114800"/>
           </a:xfrm>
           <a:prstGeom prst="rect">
             <a:avLst/>
@@ -4314,38 +4589,15 @@
               </a:defRPr>
             </a:pPr>
             <a:r>
-              <a:t>質問ログと「役に立ったか」の評価を記録。良質な回答を学習し、不要なものを除いて回答精度を高める仕組みを構築。</a:t>
-            </a:r>
-          </a:p>
-        </p:txBody>
-      </p:sp>
-      <p:sp>
-        <p:nvSpPr>
-          <p:cNvPr id="5" name="TextBox 4"/>
-          <p:cNvSpPr txBox="1"/>
-          <p:nvPr/>
-        </p:nvSpPr>
-        <p:spPr>
-          <a:xfrm>
-            <a:off x="685800" y="3931920"/>
-            <a:ext cx="10820095" cy="1828800"/>
-          </a:xfrm>
-          <a:prstGeom prst="rect">
-            <a:avLst/>
-          </a:prstGeom>
-          <a:noFill/>
-        </p:spPr>
-        <p:txBody>
-          <a:bodyPr wrap="square">
-            <a:spAutoFit/>
-          </a:bodyPr>
-          <a:lstStyle/>
+              <a:t>🔴 ワイヤ送給のもたつき: 3回検出 [警告基準: 2回以上]</a:t>
+            </a:r>
+          </a:p>
           <a:p>
             <a:pPr>
               <a:spcAft>
                 <a:spcPts val="1000"/>
               </a:spcAft>
-              <a:defRPr sz="1400" b="1">
+              <a:defRPr sz="1400">
                 <a:solidFill>
                   <a:srgbClr val="F3F4F6"/>
                 </a:solidFill>
@@ -4353,7 +4605,23 @@
               </a:defRPr>
             </a:pPr>
             <a:r>
-              <a:t>このアプリは単なる点検表のデジタル化ではありません。現場がより安全に働き、故障を防ぎ、設備を最高の状態で稼働させ続けるためのツールです。</a:t>
+              <a:t>🟡 ワイヤの滑り: 2回検出 [注意基準: 1回以上]</a:t>
+            </a:r>
+          </a:p>
+          <a:p>
+            <a:pPr>
+              <a:spcAft>
+                <a:spcPts val="1000"/>
+              </a:spcAft>
+              <a:defRPr sz="1400">
+                <a:solidFill>
+                  <a:srgbClr val="F3F4F6"/>
+                </a:solidFill>
+                <a:latin typeface="Yu Gothic"/>
+              </a:defRPr>
+            </a:pPr>
+            <a:r>
+              <a:t>🔧 推奨アクション: 点検記録より「もたつき」「滑り」の再発傾向を検知。金属粉による詰まりを防ぐため、次回の段取り替え時にライナー交換を推奨します。</a:t>
             </a:r>
           </a:p>
         </p:txBody>

</xml_diff>

<commit_message>
Restructure presentation to 11 slides: add closing slide ご清聴ありがとうございました
</commit_message>
<xml_diff>
--- a/seibi_presentation.pptx
+++ b/seibi_presentation.pptx
@@ -15,6 +15,7 @@
     <p:sldId id="263" r:id="rId14"/>
     <p:sldId id="264" r:id="rId15"/>
     <p:sldId id="265" r:id="rId16"/>
+    <p:sldId id="266" r:id="rId17"/>
   </p:sldIdLst>
   <p:sldSz cx="12191695" cy="6858000" type="screen4x3"/>
   <p:notesSz cx="6858000" cy="9144000"/>
@@ -3384,6 +3385,84 @@
             </a:pPr>
             <a:r>
               <a:t>このアプリは単なる点検表のデジタル化ではありません。現場がより安全に働き、故障を防ぎ、設備を最高の状態で稼働させ続けるためのツールです。</a:t>
+            </a:r>
+          </a:p>
+        </p:txBody>
+      </p:sp>
+    </p:spTree>
+  </p:cSld>
+  <p:clrMapOvr>
+    <a:masterClrMapping/>
+  </p:clrMapOvr>
+</p:sld>
+</file>
+
+<file path=ppt/slides/slide11.xml><?xml version="1.0" encoding="utf-8"?>
+<p:sld xmlns:a="http://schemas.openxmlformats.org/drawingml/2006/main" xmlns:p="http://schemas.openxmlformats.org/presentationml/2006/main" xmlns:r="http://schemas.openxmlformats.org/officeDocument/2006/relationships">
+  <p:cSld>
+    <p:bg>
+      <p:bgPr>
+        <a:solidFill>
+          <a:srgbClr val="0B0E14"/>
+        </a:solidFill>
+        <a:effectLst/>
+      </p:bgPr>
+    </p:bg>
+    <p:spTree>
+      <p:nvGrpSpPr>
+        <p:cNvPr id="1" name=""/>
+        <p:cNvGrpSpPr/>
+        <p:nvPr/>
+      </p:nvGrpSpPr>
+      <p:grpSpPr/>
+      <p:sp>
+        <p:nvSpPr>
+          <p:cNvPr id="2" name="TextBox 1"/>
+          <p:cNvSpPr txBox="1"/>
+          <p:nvPr/>
+        </p:nvSpPr>
+        <p:spPr>
+          <a:xfrm>
+            <a:off x="914400" y="2286000"/>
+            <a:ext cx="10362895" cy="2743200"/>
+          </a:xfrm>
+          <a:prstGeom prst="rect">
+            <a:avLst/>
+          </a:prstGeom>
+          <a:noFill/>
+        </p:spPr>
+        <p:txBody>
+          <a:bodyPr wrap="square">
+            <a:spAutoFit/>
+          </a:bodyPr>
+          <a:lstStyle/>
+          <a:p>
+            <a:pPr>
+              <a:spcAft>
+                <a:spcPts val="2000"/>
+              </a:spcAft>
+              <a:defRPr sz="5400" b="1">
+                <a:solidFill>
+                  <a:srgbClr val="10B981"/>
+                </a:solidFill>
+                <a:latin typeface="Yu Gothic"/>
+              </a:defRPr>
+            </a:pPr>
+            <a:r>
+              <a:t>ご清聴ありがとうございました</a:t>
+            </a:r>
+          </a:p>
+          <a:p>
+            <a:pPr>
+              <a:defRPr sz="2400">
+                <a:solidFill>
+                  <a:srgbClr val="9CA3AF"/>
+                </a:solidFill>
+                <a:latin typeface="Yu Gothic"/>
+              </a:defRPr>
+            </a:pPr>
+            <a:r>
+              <a:t>設備管理システム — Seibi</a:t>
             </a:r>
           </a:p>
         </p:txBody>

</xml_diff>

<commit_message>
Update presentation to 12-slide Light Theme layout: reduced text density, restored Layout Map slide, high contrast for factory projectors
</commit_message>
<xml_diff>
--- a/seibi_presentation.pptx
+++ b/seibi_presentation.pptx
@@ -16,6 +16,7 @@
     <p:sldId id="264" r:id="rId15"/>
     <p:sldId id="265" r:id="rId16"/>
     <p:sldId id="266" r:id="rId17"/>
+    <p:sldId id="267" r:id="rId18"/>
   </p:sldIdLst>
   <p:sldSz cx="12191695" cy="6858000" type="screen4x3"/>
   <p:notesSz cx="6858000" cy="9144000"/>
@@ -3094,7 +3095,7 @@
     <p:bg>
       <p:bgPr>
         <a:solidFill>
-          <a:srgbClr val="0B0E14"/>
+          <a:srgbClr val="F8FAFC"/>
         </a:solidFill>
         <a:effectLst/>
       </p:bgPr>
@@ -3114,8 +3115,8 @@
         </p:nvSpPr>
         <p:spPr>
           <a:xfrm>
-            <a:off x="914400" y="2011680"/>
-            <a:ext cx="10362895" cy="1828800"/>
+            <a:off x="914400" y="1828800"/>
+            <a:ext cx="10362895" cy="3200400"/>
           </a:xfrm>
           <a:prstGeom prst="rect">
             <a:avLst/>
@@ -3129,11 +3130,30 @@
           <a:lstStyle/>
           <a:p>
             <a:pPr>
-              <a:defRPr sz="7200" b="1">
-                <a:solidFill>
-                  <a:srgbClr val="3B82F6"/>
-                </a:solidFill>
-                <a:latin typeface="Yu Gothic"/>
+              <a:spcAft>
+                <a:spcPts val="1000"/>
+              </a:spcAft>
+              <a:defRPr sz="1800" b="1">
+                <a:solidFill>
+                  <a:srgbClr val="2563EB"/>
+                </a:solidFill>
+                <a:latin typeface="Noto Sans JP"/>
+              </a:defRPr>
+            </a:pPr>
+            <a:r>
+              <a:t>現場改善プロジェクト報告</a:t>
+            </a:r>
+          </a:p>
+          <a:p>
+            <a:pPr>
+              <a:spcAft>
+                <a:spcPts val="1000"/>
+              </a:spcAft>
+              <a:defRPr sz="6400" b="1">
+                <a:solidFill>
+                  <a:srgbClr val="2563EB"/>
+                </a:solidFill>
+                <a:latin typeface="Noto Sans JP"/>
               </a:defRPr>
             </a:pPr>
             <a:r>
@@ -3142,70 +3162,31 @@
           </a:p>
           <a:p>
             <a:pPr>
-              <a:spcBef>
-                <a:spcPts val="1000"/>
-              </a:spcBef>
-              <a:defRPr sz="2400">
-                <a:solidFill>
-                  <a:srgbClr val="F3F4F6"/>
-                </a:solidFill>
-                <a:latin typeface="Yu Gothic"/>
+              <a:spcAft>
+                <a:spcPts val="3000"/>
+              </a:spcAft>
+              <a:defRPr sz="2600" b="1">
+                <a:solidFill>
+                  <a:srgbClr val="0F172A"/>
+                </a:solidFill>
+                <a:latin typeface="Noto Sans JP"/>
               </a:defRPr>
             </a:pPr>
             <a:r>
               <a:t>設備点検・不具合管理アプリのご紹介</a:t>
             </a:r>
           </a:p>
-        </p:txBody>
-      </p:sp>
-      <p:sp>
-        <p:nvSpPr>
-          <p:cNvPr id="3" name="TextBox 2"/>
-          <p:cNvSpPr txBox="1"/>
-          <p:nvPr/>
-        </p:nvSpPr>
-        <p:spPr>
-          <a:xfrm>
-            <a:off x="914400" y="4114800"/>
-            <a:ext cx="10362895" cy="1371600"/>
-          </a:xfrm>
-          <a:prstGeom prst="rect">
-            <a:avLst/>
-          </a:prstGeom>
-          <a:noFill/>
-        </p:spPr>
-        <p:txBody>
-          <a:bodyPr wrap="none">
-            <a:spAutoFit/>
-          </a:bodyPr>
-          <a:lstStyle/>
-          <a:p>
-            <a:pPr>
-              <a:defRPr sz="1600">
-                <a:solidFill>
-                  <a:srgbClr val="9CA3AF"/>
-                </a:solidFill>
-                <a:latin typeface="Yu Gothic"/>
-              </a:defRPr>
-            </a:pPr>
-            <a:r>
-              <a:t>点検業務のデジタル化から、リアルタイム状況共有、AI修理サポートまで</a:t>
-            </a:r>
-          </a:p>
-          <a:p>
-            <a:pPr>
-              <a:spcBef>
-                <a:spcPts val="500"/>
-              </a:spcBef>
-              <a:defRPr sz="1400">
-                <a:solidFill>
-                  <a:srgbClr val="10B981"/>
-                </a:solidFill>
-                <a:latin typeface="Yu Gothic"/>
-              </a:defRPr>
-            </a:pPr>
-            <a:r>
-              <a:t>溶接チーム マーク</a:t>
+          <a:p>
+            <a:pPr>
+              <a:defRPr sz="1800">
+                <a:solidFill>
+                  <a:srgbClr val="475569"/>
+                </a:solidFill>
+                <a:latin typeface="Noto Sans JP"/>
+              </a:defRPr>
+            </a:pPr>
+            <a:r>
+              <a:t>溶接ラインチーム</a:t>
             </a:r>
           </a:p>
         </p:txBody>
@@ -3224,7 +3205,7 @@
     <p:bg>
       <p:bgPr>
         <a:solidFill>
-          <a:srgbClr val="0B0E14"/>
+          <a:srgbClr val="F8FAFC"/>
         </a:solidFill>
         <a:effectLst/>
       </p:bgPr>
@@ -3244,8 +3225,8 @@
         </p:nvSpPr>
         <p:spPr>
           <a:xfrm>
-            <a:off x="685800" y="457200"/>
-            <a:ext cx="10820095" cy="731520"/>
+            <a:off x="685800" y="365760"/>
+            <a:ext cx="10820095" cy="914400"/>
           </a:xfrm>
           <a:prstGeom prst="rect">
             <a:avLst/>
@@ -3261,13 +3242,29 @@
             <a:pPr>
               <a:defRPr sz="2800" b="1">
                 <a:solidFill>
-                  <a:srgbClr val="3B82F6"/>
-                </a:solidFill>
-                <a:latin typeface="Yu Gothic"/>
-              </a:defRPr>
-            </a:pPr>
-            <a:r>
-              <a:t>今後の展望：AI機能の高度化</a:t>
+                  <a:srgbClr val="0F172A"/>
+                </a:solidFill>
+                <a:latin typeface="Noto Sans JP"/>
+              </a:defRPr>
+            </a:pPr>
+            <a:r>
+              <a:t>今後の展望：データ主導の保全</a:t>
+            </a:r>
+          </a:p>
+          <a:p>
+            <a:pPr>
+              <a:spcBef>
+                <a:spcPts val="400"/>
+              </a:spcBef>
+              <a:defRPr sz="1500">
+                <a:solidFill>
+                  <a:srgbClr val="475569"/>
+                </a:solidFill>
+                <a:latin typeface="Noto Sans JP"/>
+              </a:defRPr>
+            </a:pPr>
+            <a:r>
+              <a:t>点検ログの傾向から故障を予測し未然防止</a:t>
             </a:r>
           </a:p>
         </p:txBody>
@@ -3281,7 +3278,7 @@
         <p:spPr>
           <a:xfrm>
             <a:off x="685800" y="1645920"/>
-            <a:ext cx="5029200" cy="2011680"/>
+            <a:ext cx="5303520" cy="4572000"/>
           </a:xfrm>
           <a:prstGeom prst="rect">
             <a:avLst/>
@@ -3293,20 +3290,37 @@
             <a:spAutoFit/>
           </a:bodyPr>
           <a:lstStyle/>
+          <a:p/>
           <a:p>
             <a:pPr>
               <a:spcAft>
-                <a:spcPts val="1000"/>
+                <a:spcPts val="1200"/>
               </a:spcAft>
-              <a:defRPr sz="1400" b="1">
-                <a:solidFill>
-                  <a:srgbClr val="F3F4F6"/>
-                </a:solidFill>
-                <a:latin typeface="Yu Gothic"/>
-              </a:defRPr>
-            </a:pPr>
-            <a:r>
-              <a:t>一部の設備だけでなく、工場内のすべての主要設備の手順書・図面データをAIへ順次取り込み、サポート範囲を全域へ拡大。</a:t>
+              <a:defRPr sz="1700">
+                <a:solidFill>
+                  <a:srgbClr val="0F172A"/>
+                </a:solidFill>
+                <a:latin typeface="Noto Sans JP"/>
+              </a:defRPr>
+            </a:pPr>
+            <a:r>
+              <a:t>⚡ 溶接機ログの予兆検知: 点検表の「ワイヤ送給のもたつき」や「滑り」の頻度から、ライン停止のサインを検知。</a:t>
+            </a:r>
+          </a:p>
+          <a:p>
+            <a:pPr>
+              <a:spcAft>
+                <a:spcPts val="1200"/>
+              </a:spcAft>
+              <a:defRPr sz="1700">
+                <a:solidFill>
+                  <a:srgbClr val="0F172A"/>
+                </a:solidFill>
+                <a:latin typeface="Noto Sans JP"/>
+              </a:defRPr>
+            </a:pPr>
+            <a:r>
+              <a:t>🛠️ 予測交換によるダウンタイムゼロ: ライナーの詰まりや駆動部の摩耗期を特定し、次回段取り時に交換してトラブルを防止。</a:t>
             </a:r>
           </a:p>
         </p:txBody>
@@ -3320,7 +3334,7 @@
         <p:spPr>
           <a:xfrm>
             <a:off x="6217920" y="1645920"/>
-            <a:ext cx="5029200" cy="2011680"/>
+            <a:ext cx="5212080" cy="4572000"/>
           </a:xfrm>
           <a:prstGeom prst="rect">
             <a:avLst/>
@@ -3335,56 +3349,65 @@
           <a:p>
             <a:pPr>
               <a:spcAft>
-                <a:spcPts val="1000"/>
+                <a:spcPts val="1600"/>
               </a:spcAft>
-              <a:defRPr sz="1400" b="1">
-                <a:solidFill>
-                  <a:srgbClr val="F3F4F6"/>
-                </a:solidFill>
-                <a:latin typeface="Yu Gothic"/>
-              </a:defRPr>
-            </a:pPr>
-            <a:r>
-              <a:t>質問ログと「役に立ったか」の評価を記録。良質な回答を学習し、不要なものを除いて回答精度を高める仕組みを構築。</a:t>
-            </a:r>
-          </a:p>
-        </p:txBody>
-      </p:sp>
-      <p:sp>
-        <p:nvSpPr>
-          <p:cNvPr id="5" name="TextBox 4"/>
-          <p:cNvSpPr txBox="1"/>
-          <p:nvPr/>
-        </p:nvSpPr>
-        <p:spPr>
-          <a:xfrm>
-            <a:off x="685800" y="3931920"/>
-            <a:ext cx="10820095" cy="1828800"/>
-          </a:xfrm>
-          <a:prstGeom prst="rect">
-            <a:avLst/>
-          </a:prstGeom>
-          <a:noFill/>
-        </p:spPr>
-        <p:txBody>
-          <a:bodyPr wrap="square">
-            <a:spAutoFit/>
-          </a:bodyPr>
-          <a:lstStyle/>
+              <a:defRPr sz="2000" b="1">
+                <a:solidFill>
+                  <a:srgbClr val="2563EB"/>
+                </a:solidFill>
+                <a:latin typeface="Noto Sans JP"/>
+              </a:defRPr>
+            </a:pPr>
+            <a:r>
+              <a:t>溶接機 状態モニター（過去5ヶ月間）</a:t>
+            </a:r>
+          </a:p>
           <a:p>
             <a:pPr>
               <a:spcAft>
-                <a:spcPts val="1000"/>
+                <a:spcPts val="1200"/>
               </a:spcAft>
-              <a:defRPr sz="1400" b="1">
-                <a:solidFill>
-                  <a:srgbClr val="F3F4F6"/>
-                </a:solidFill>
-                <a:latin typeface="Yu Gothic"/>
-              </a:defRPr>
-            </a:pPr>
-            <a:r>
-              <a:t>このアプリは単なる点検表のデジタル化ではありません。現場がより安全に働き、故障を防ぎ、設備を最高の状態で稼働させ続けるためのツールです。</a:t>
+              <a:defRPr sz="1700">
+                <a:solidFill>
+                  <a:srgbClr val="0F172A"/>
+                </a:solidFill>
+                <a:latin typeface="Noto Sans JP"/>
+              </a:defRPr>
+            </a:pPr>
+            <a:r>
+              <a:t>🔴 ワイヤ送給のもたつき: 3回検出 [警告基準: 2回以上]</a:t>
+            </a:r>
+          </a:p>
+          <a:p>
+            <a:pPr>
+              <a:spcAft>
+                <a:spcPts val="1200"/>
+              </a:spcAft>
+              <a:defRPr sz="1700">
+                <a:solidFill>
+                  <a:srgbClr val="0F172A"/>
+                </a:solidFill>
+                <a:latin typeface="Noto Sans JP"/>
+              </a:defRPr>
+            </a:pPr>
+            <a:r>
+              <a:t>🟡 ワイヤの滑り: 2回検出 [注意基準: 1回以上]</a:t>
+            </a:r>
+          </a:p>
+          <a:p>
+            <a:pPr>
+              <a:spcAft>
+                <a:spcPts val="1200"/>
+              </a:spcAft>
+              <a:defRPr sz="1700">
+                <a:solidFill>
+                  <a:srgbClr val="0F172A"/>
+                </a:solidFill>
+                <a:latin typeface="Noto Sans JP"/>
+              </a:defRPr>
+            </a:pPr>
+            <a:r>
+              <a:t>🔧 推奨アクション: 点検記録より「もたつき」「滑り」の再発傾向を検知。金属粉による詰まりを防ぐため、次回段取り替え時にコンジットライナー交換を推奨します。</a:t>
             </a:r>
           </a:p>
         </p:txBody>
@@ -3403,7 +3426,7 @@
     <p:bg>
       <p:bgPr>
         <a:solidFill>
-          <a:srgbClr val="0B0E14"/>
+          <a:srgbClr val="F8FAFC"/>
         </a:solidFill>
         <a:effectLst/>
       </p:bgPr>
@@ -3423,6 +3446,249 @@
         </p:nvSpPr>
         <p:spPr>
           <a:xfrm>
+            <a:off x="685800" y="365760"/>
+            <a:ext cx="10820095" cy="914400"/>
+          </a:xfrm>
+          <a:prstGeom prst="rect">
+            <a:avLst/>
+          </a:prstGeom>
+          <a:noFill/>
+        </p:spPr>
+        <p:txBody>
+          <a:bodyPr wrap="square">
+            <a:spAutoFit/>
+          </a:bodyPr>
+          <a:lstStyle/>
+          <a:p>
+            <a:pPr>
+              <a:defRPr sz="2800" b="1">
+                <a:solidFill>
+                  <a:srgbClr val="0F172A"/>
+                </a:solidFill>
+                <a:latin typeface="Noto Sans JP"/>
+              </a:defRPr>
+            </a:pPr>
+            <a:r>
+              <a:t>今後の展望：AI機能の高度化</a:t>
+            </a:r>
+          </a:p>
+          <a:p>
+            <a:pPr>
+              <a:spcBef>
+                <a:spcPts val="400"/>
+              </a:spcBef>
+              <a:defRPr sz="1500">
+                <a:solidFill>
+                  <a:srgbClr val="475569"/>
+                </a:solidFill>
+                <a:latin typeface="Noto Sans JP"/>
+              </a:defRPr>
+            </a:pPr>
+            <a:r>
+              <a:t>全設備のカバーとAI自律学習の確立</a:t>
+            </a:r>
+          </a:p>
+        </p:txBody>
+      </p:sp>
+      <p:sp>
+        <p:nvSpPr>
+          <p:cNvPr id="3" name="TextBox 2"/>
+          <p:cNvSpPr txBox="1"/>
+          <p:nvPr/>
+        </p:nvSpPr>
+        <p:spPr>
+          <a:xfrm>
+            <a:off x="685800" y="1645920"/>
+            <a:ext cx="5212080" cy="2011680"/>
+          </a:xfrm>
+          <a:prstGeom prst="rect">
+            <a:avLst/>
+          </a:prstGeom>
+          <a:noFill/>
+        </p:spPr>
+        <p:txBody>
+          <a:bodyPr wrap="square">
+            <a:spAutoFit/>
+          </a:bodyPr>
+          <a:lstStyle/>
+          <a:p>
+            <a:pPr>
+              <a:spcAft>
+                <a:spcPts val="1000"/>
+              </a:spcAft>
+              <a:defRPr sz="2000" b="1">
+                <a:solidFill>
+                  <a:srgbClr val="2563EB"/>
+                </a:solidFill>
+                <a:latin typeface="Noto Sans JP"/>
+              </a:defRPr>
+            </a:pPr>
+            <a:r>
+              <a:t>📚 AI対応マニュアルの拡大</a:t>
+            </a:r>
+          </a:p>
+          <a:p>
+            <a:pPr>
+              <a:spcAft>
+                <a:spcPts val="1200"/>
+              </a:spcAft>
+              <a:defRPr sz="1700">
+                <a:solidFill>
+                  <a:srgbClr val="0F172A"/>
+                </a:solidFill>
+                <a:latin typeface="Noto Sans JP"/>
+              </a:defRPr>
+            </a:pPr>
+            <a:r>
+              <a:t>工場内のすべての主要設備の手順書・図面データをAIへ順次取り込み、全域をサポート可能にします。</a:t>
+            </a:r>
+          </a:p>
+        </p:txBody>
+      </p:sp>
+      <p:sp>
+        <p:nvSpPr>
+          <p:cNvPr id="4" name="TextBox 3"/>
+          <p:cNvSpPr txBox="1"/>
+          <p:nvPr/>
+        </p:nvSpPr>
+        <p:spPr>
+          <a:xfrm>
+            <a:off x="6217920" y="1645920"/>
+            <a:ext cx="5212080" cy="2011680"/>
+          </a:xfrm>
+          <a:prstGeom prst="rect">
+            <a:avLst/>
+          </a:prstGeom>
+          <a:noFill/>
+        </p:spPr>
+        <p:txBody>
+          <a:bodyPr wrap="square">
+            <a:spAutoFit/>
+          </a:bodyPr>
+          <a:lstStyle/>
+          <a:p>
+            <a:pPr>
+              <a:spcAft>
+                <a:spcPts val="1000"/>
+              </a:spcAft>
+              <a:defRPr sz="2000" b="1">
+                <a:solidFill>
+                  <a:srgbClr val="059669"/>
+                </a:solidFill>
+                <a:latin typeface="Noto Sans JP"/>
+              </a:defRPr>
+            </a:pPr>
+            <a:r>
+              <a:t>🔄 使うほど賢くなるAI学習ループ</a:t>
+            </a:r>
+          </a:p>
+          <a:p>
+            <a:pPr>
+              <a:spcAft>
+                <a:spcPts val="1200"/>
+              </a:spcAft>
+              <a:defRPr sz="1700">
+                <a:solidFill>
+                  <a:srgbClr val="0F172A"/>
+                </a:solidFill>
+                <a:latin typeface="Noto Sans JP"/>
+              </a:defRPr>
+            </a:pPr>
+            <a:r>
+              <a:t>質問ログとフィードバック（役に立ったか）を分析。良回答を保存・学習し、精度を向上させます。</a:t>
+            </a:r>
+          </a:p>
+        </p:txBody>
+      </p:sp>
+      <p:sp>
+        <p:nvSpPr>
+          <p:cNvPr id="5" name="TextBox 4"/>
+          <p:cNvSpPr txBox="1"/>
+          <p:nvPr/>
+        </p:nvSpPr>
+        <p:spPr>
+          <a:xfrm>
+            <a:off x="685800" y="4114800"/>
+            <a:ext cx="10820095" cy="1645920"/>
+          </a:xfrm>
+          <a:prstGeom prst="rect">
+            <a:avLst/>
+          </a:prstGeom>
+          <a:noFill/>
+        </p:spPr>
+        <p:txBody>
+          <a:bodyPr wrap="square">
+            <a:spAutoFit/>
+          </a:bodyPr>
+          <a:lstStyle/>
+          <a:p>
+            <a:pPr>
+              <a:spcAft>
+                <a:spcPts val="800"/>
+              </a:spcAft>
+              <a:defRPr sz="2000" b="1">
+                <a:solidFill>
+                  <a:srgbClr val="0F172A"/>
+                </a:solidFill>
+                <a:latin typeface="Noto Sans JP"/>
+              </a:defRPr>
+            </a:pPr>
+            <a:r>
+              <a:t>💡 まとめ</a:t>
+            </a:r>
+          </a:p>
+          <a:p>
+            <a:pPr>
+              <a:spcAft>
+                <a:spcPts val="1200"/>
+              </a:spcAft>
+              <a:defRPr sz="1700">
+                <a:solidFill>
+                  <a:srgbClr val="0F172A"/>
+                </a:solidFill>
+                <a:latin typeface="Noto Sans JP"/>
+              </a:defRPr>
+            </a:pPr>
+            <a:r>
+              <a:t>Seibi: 製造現場のダウンタイムをゼロにし、組織の保全力と稼働率を最大化するソリューション</a:t>
+            </a:r>
+          </a:p>
+        </p:txBody>
+      </p:sp>
+    </p:spTree>
+  </p:cSld>
+  <p:clrMapOvr>
+    <a:masterClrMapping/>
+  </p:clrMapOvr>
+</p:sld>
+</file>
+
+<file path=ppt/slides/slide12.xml><?xml version="1.0" encoding="utf-8"?>
+<p:sld xmlns:a="http://schemas.openxmlformats.org/drawingml/2006/main" xmlns:p="http://schemas.openxmlformats.org/presentationml/2006/main" xmlns:r="http://schemas.openxmlformats.org/officeDocument/2006/relationships">
+  <p:cSld>
+    <p:bg>
+      <p:bgPr>
+        <a:solidFill>
+          <a:srgbClr val="F8FAFC"/>
+        </a:solidFill>
+        <a:effectLst/>
+      </p:bgPr>
+    </p:bg>
+    <p:spTree>
+      <p:nvGrpSpPr>
+        <p:cNvPr id="1" name=""/>
+        <p:cNvGrpSpPr/>
+        <p:nvPr/>
+      </p:nvGrpSpPr>
+      <p:grpSpPr/>
+      <p:sp>
+        <p:nvSpPr>
+          <p:cNvPr id="2" name="TextBox 1"/>
+          <p:cNvSpPr txBox="1"/>
+          <p:nvPr/>
+        </p:nvSpPr>
+        <p:spPr>
+          <a:xfrm>
             <a:off x="914400" y="2286000"/>
             <a:ext cx="10362895" cy="2743200"/>
           </a:xfrm>
@@ -3439,13 +3705,13 @@
           <a:p>
             <a:pPr>
               <a:spcAft>
-                <a:spcPts val="2000"/>
+                <a:spcPts val="1600"/>
               </a:spcAft>
-              <a:defRPr sz="5400" b="1">
-                <a:solidFill>
-                  <a:srgbClr val="10B981"/>
-                </a:solidFill>
-                <a:latin typeface="Yu Gothic"/>
+              <a:defRPr sz="5200" b="1">
+                <a:solidFill>
+                  <a:srgbClr val="059669"/>
+                </a:solidFill>
+                <a:latin typeface="Noto Sans JP"/>
               </a:defRPr>
             </a:pPr>
             <a:r>
@@ -3456,9 +3722,9 @@
             <a:pPr>
               <a:defRPr sz="2400">
                 <a:solidFill>
-                  <a:srgbClr val="9CA3AF"/>
-                </a:solidFill>
-                <a:latin typeface="Yu Gothic"/>
+                  <a:srgbClr val="475569"/>
+                </a:solidFill>
+                <a:latin typeface="Noto Sans JP"/>
               </a:defRPr>
             </a:pPr>
             <a:r>
@@ -3481,7 +3747,7 @@
     <p:bg>
       <p:bgPr>
         <a:solidFill>
-          <a:srgbClr val="0B0E14"/>
+          <a:srgbClr val="F8FAFC"/>
         </a:solidFill>
         <a:effectLst/>
       </p:bgPr>
@@ -3501,8 +3767,8 @@
         </p:nvSpPr>
         <p:spPr>
           <a:xfrm>
-            <a:off x="685800" y="457200"/>
-            <a:ext cx="10820095" cy="731520"/>
+            <a:off x="685800" y="365760"/>
+            <a:ext cx="10820095" cy="914400"/>
           </a:xfrm>
           <a:prstGeom prst="rect">
             <a:avLst/>
@@ -3518,13 +3784,29 @@
             <a:pPr>
               <a:defRPr sz="2800" b="1">
                 <a:solidFill>
-                  <a:srgbClr val="3B82F6"/>
-                </a:solidFill>
-                <a:latin typeface="Yu Gothic"/>
+                  <a:srgbClr val="0F172A"/>
+                </a:solidFill>
+                <a:latin typeface="Noto Sans JP"/>
               </a:defRPr>
             </a:pPr>
             <a:r>
               <a:t>背景と課題</a:t>
+            </a:r>
+          </a:p>
+          <a:p>
+            <a:pPr>
+              <a:spcBef>
+                <a:spcPts val="400"/>
+              </a:spcBef>
+              <a:defRPr sz="1500">
+                <a:solidFill>
+                  <a:srgbClr val="475569"/>
+                </a:solidFill>
+                <a:latin typeface="Noto Sans JP"/>
+              </a:defRPr>
+            </a:pPr>
+            <a:r>
+              <a:t>紙の点検表運用による3つの現場課題</a:t>
             </a:r>
           </a:p>
         </p:txBody>
@@ -3538,7 +3820,7 @@
         <p:spPr>
           <a:xfrm>
             <a:off x="685800" y="1645920"/>
-            <a:ext cx="5029200" cy="4114800"/>
+            <a:ext cx="3328416" cy="4114800"/>
           </a:xfrm>
           <a:prstGeom prst="rect">
             <a:avLst/>
@@ -3553,33 +3835,33 @@
           <a:p>
             <a:pPr>
               <a:spcAft>
-                <a:spcPts val="1000"/>
+                <a:spcPts val="1400"/>
               </a:spcAft>
-              <a:defRPr sz="1400" b="1">
-                <a:solidFill>
-                  <a:srgbClr val="F3F4F6"/>
-                </a:solidFill>
-                <a:latin typeface="Yu Gothic"/>
-              </a:defRPr>
-            </a:pPr>
-            <a:r>
-              <a:t>❌ 点検履歴の散逸: 手書きの点検表は提出後にファイル保管されるか処分され、後から検索できるデジタル記録が残らない。</a:t>
-            </a:r>
-          </a:p>
-          <a:p>
-            <a:pPr>
-              <a:spcAft>
-                <a:spcPts val="1000"/>
-              </a:spcAft>
-              <a:defRPr sz="1400">
-                <a:solidFill>
-                  <a:srgbClr val="F3F4F6"/>
-                </a:solidFill>
-                <a:latin typeface="Yu Gothic"/>
-              </a:defRPr>
-            </a:pPr>
-            <a:r>
-              <a:t>❌ 過去の状況確認不可: 過去にどんな不具合があったのか、先月や昨年に設備に何が起きたのかを確認する方法がない。</a:t>
+              <a:defRPr sz="2000" b="1">
+                <a:solidFill>
+                  <a:srgbClr val="2563EB"/>
+                </a:solidFill>
+                <a:latin typeface="Noto Sans JP"/>
+              </a:defRPr>
+            </a:pPr>
+            <a:r>
+              <a:t>📁 履歴の散逸</a:t>
+            </a:r>
+          </a:p>
+          <a:p>
+            <a:pPr>
+              <a:lnSpc>
+                <a:spcPct val="140000"/>
+              </a:lnSpc>
+              <a:defRPr sz="1600">
+                <a:solidFill>
+                  <a:srgbClr val="0F172A"/>
+                </a:solidFill>
+                <a:latin typeface="Noto Sans JP"/>
+              </a:defRPr>
+            </a:pPr>
+            <a:r>
+              <a:t>手書きの点検表は提出後に保管または破棄され、検索可能なデジタル記録が残らない状態でした。</a:t>
             </a:r>
           </a:p>
         </p:txBody>
@@ -3592,8 +3874,8 @@
         </p:nvSpPr>
         <p:spPr>
           <a:xfrm>
-            <a:off x="6217920" y="1645920"/>
-            <a:ext cx="5029200" cy="4114800"/>
+            <a:off x="4288536" y="1645920"/>
+            <a:ext cx="3328416" cy="4114800"/>
           </a:xfrm>
           <a:prstGeom prst="rect">
             <a:avLst/>
@@ -3608,33 +3890,88 @@
           <a:p>
             <a:pPr>
               <a:spcAft>
-                <a:spcPts val="1000"/>
+                <a:spcPts val="1400"/>
               </a:spcAft>
-              <a:defRPr sz="1400" b="1">
-                <a:solidFill>
-                  <a:srgbClr val="F3F4F6"/>
-                </a:solidFill>
-                <a:latin typeface="Yu Gothic"/>
-              </a:defRPr>
-            </a:pPr>
-            <a:r>
-              <a:t>⚠️ 繰り返す不具合の放置: 不具合が再発しても個人の記憶に頼るしかなく、不具合が実際に修理されたかを追跡する仕組みもない。</a:t>
-            </a:r>
-          </a:p>
+              <a:defRPr sz="2000" b="1">
+                <a:solidFill>
+                  <a:srgbClr val="2563EB"/>
+                </a:solidFill>
+                <a:latin typeface="Noto Sans JP"/>
+              </a:defRPr>
+            </a:pPr>
+            <a:r>
+              <a:t>🔄 追跡の困難</a:t>
+            </a:r>
+          </a:p>
+          <a:p>
+            <a:pPr>
+              <a:lnSpc>
+                <a:spcPct val="140000"/>
+              </a:lnSpc>
+              <a:defRPr sz="1600">
+                <a:solidFill>
+                  <a:srgbClr val="0F172A"/>
+                </a:solidFill>
+                <a:latin typeface="Noto Sans JP"/>
+              </a:defRPr>
+            </a:pPr>
+            <a:r>
+              <a:t>同じトラブルが繰り返し発生しても記憶に頼るしかなく、発見された異常が確実に修理されたか確認できませんでした。</a:t>
+            </a:r>
+          </a:p>
+        </p:txBody>
+      </p:sp>
+      <p:sp>
+        <p:nvSpPr>
+          <p:cNvPr id="5" name="TextBox 4"/>
+          <p:cNvSpPr txBox="1"/>
+          <p:nvPr/>
+        </p:nvSpPr>
+        <p:spPr>
+          <a:xfrm>
+            <a:off x="7891271" y="1645920"/>
+            <a:ext cx="3328416" cy="4114800"/>
+          </a:xfrm>
+          <a:prstGeom prst="rect">
+            <a:avLst/>
+          </a:prstGeom>
+          <a:noFill/>
+        </p:spPr>
+        <p:txBody>
+          <a:bodyPr wrap="square">
+            <a:spAutoFit/>
+          </a:bodyPr>
+          <a:lstStyle/>
           <a:p>
             <a:pPr>
               <a:spcAft>
-                <a:spcPts val="1000"/>
+                <a:spcPts val="1400"/>
               </a:spcAft>
-              <a:defRPr sz="1400">
-                <a:solidFill>
-                  <a:srgbClr val="F3F4F6"/>
-                </a:solidFill>
-                <a:latin typeface="Yu Gothic"/>
-              </a:defRPr>
-            </a:pPr>
-            <a:r>
-              <a:t>⚠️ マニュアル参照の非効率: 修理中に手順を確認したい場合、分厚い紙マニュアルをめくるか周りに聞くしかない。</a:t>
+              <a:defRPr sz="2000" b="1">
+                <a:solidFill>
+                  <a:srgbClr val="2563EB"/>
+                </a:solidFill>
+                <a:latin typeface="Noto Sans JP"/>
+              </a:defRPr>
+            </a:pPr>
+            <a:r>
+              <a:t>📖 作業の非効率</a:t>
+            </a:r>
+          </a:p>
+          <a:p>
+            <a:pPr>
+              <a:lnSpc>
+                <a:spcPct val="140000"/>
+              </a:lnSpc>
+              <a:defRPr sz="1600">
+                <a:solidFill>
+                  <a:srgbClr val="0F172A"/>
+                </a:solidFill>
+                <a:latin typeface="Noto Sans JP"/>
+              </a:defRPr>
+            </a:pPr>
+            <a:r>
+              <a:t>トラブル対応時に紙のマニュアルを探してめくるか、特定の人に質問するしか選択肢がありませんでした。</a:t>
             </a:r>
           </a:p>
         </p:txBody>
@@ -3653,7 +3990,7 @@
     <p:bg>
       <p:bgPr>
         <a:solidFill>
-          <a:srgbClr val="0B0E14"/>
+          <a:srgbClr val="F8FAFC"/>
         </a:solidFill>
         <a:effectLst/>
       </p:bgPr>
@@ -3673,8 +4010,8 @@
         </p:nvSpPr>
         <p:spPr>
           <a:xfrm>
-            <a:off x="685800" y="1371600"/>
-            <a:ext cx="10820095" cy="1371600"/>
+            <a:off x="685800" y="365760"/>
+            <a:ext cx="10820095" cy="914400"/>
           </a:xfrm>
           <a:prstGeom prst="rect">
             <a:avLst/>
@@ -3688,15 +4025,31 @@
           <a:lstStyle/>
           <a:p>
             <a:pPr>
-              <a:defRPr sz="4400" b="1">
-                <a:solidFill>
-                  <a:srgbClr val="3B82F6"/>
-                </a:solidFill>
-                <a:latin typeface="Yu Gothic"/>
+              <a:defRPr sz="2800" b="1">
+                <a:solidFill>
+                  <a:srgbClr val="0F172A"/>
+                </a:solidFill>
+                <a:latin typeface="Noto Sans JP"/>
               </a:defRPr>
             </a:pPr>
             <a:r>
               <a:t>解決策と取り組み</a:t>
+            </a:r>
+          </a:p>
+          <a:p>
+            <a:pPr>
+              <a:spcBef>
+                <a:spcPts val="400"/>
+              </a:spcBef>
+              <a:defRPr sz="1500">
+                <a:solidFill>
+                  <a:srgbClr val="475569"/>
+                </a:solidFill>
+                <a:latin typeface="Noto Sans JP"/>
+              </a:defRPr>
+            </a:pPr>
+            <a:r>
+              <a:t>4つの主要機能で現場の課題を解決</a:t>
             </a:r>
           </a:p>
         </p:txBody>
@@ -3709,8 +4062,8 @@
         </p:nvSpPr>
         <p:spPr>
           <a:xfrm>
-            <a:off x="685800" y="2926080"/>
-            <a:ext cx="10820095" cy="2743200"/>
+            <a:off x="2286000" y="1828800"/>
+            <a:ext cx="7619695" cy="4114800"/>
           </a:xfrm>
           <a:prstGeom prst="rect">
             <a:avLst/>
@@ -3725,49 +4078,65 @@
           <a:p>
             <a:pPr>
               <a:spcAft>
-                <a:spcPts val="2000"/>
+                <a:spcPts val="2400"/>
               </a:spcAft>
               <a:defRPr sz="2200" b="1">
                 <a:solidFill>
-                  <a:srgbClr val="F3F4F6"/>
-                </a:solidFill>
-                <a:latin typeface="Yu Gothic"/>
-              </a:defRPr>
-            </a:pPr>
-            <a:r>
-              <a:t>1. 点検業務のデジタル化</a:t>
+                  <a:srgbClr val="0F172A"/>
+                </a:solidFill>
+                <a:latin typeface="Noto Sans JP"/>
+              </a:defRPr>
+            </a:pPr>
+            <a:r>
+              <a:t>1. 点検業務のデジタル化と履歴保存</a:t>
             </a:r>
           </a:p>
           <a:p>
             <a:pPr>
               <a:spcAft>
-                <a:spcPts val="2000"/>
+                <a:spcPts val="2400"/>
               </a:spcAft>
               <a:defRPr sz="2200" b="1">
                 <a:solidFill>
-                  <a:srgbClr val="F3F4F6"/>
-                </a:solidFill>
-                <a:latin typeface="Yu Gothic"/>
-              </a:defRPr>
-            </a:pPr>
-            <a:r>
-              <a:t>2. リアルタイムの状況共有と管理</a:t>
+                  <a:srgbClr val="0F172A"/>
+                </a:solidFill>
+                <a:latin typeface="Noto Sans JP"/>
+              </a:defRPr>
+            </a:pPr>
+            <a:r>
+              <a:t>2. レイアウトマップによる視覚管理</a:t>
             </a:r>
           </a:p>
           <a:p>
             <a:pPr>
               <a:spcAft>
-                <a:spcPts val="2000"/>
+                <a:spcPts val="2400"/>
               </a:spcAft>
               <a:defRPr sz="2200" b="1">
                 <a:solidFill>
-                  <a:srgbClr val="F3F4F6"/>
-                </a:solidFill>
-                <a:latin typeface="Yu Gothic"/>
-              </a:defRPr>
-            </a:pPr>
-            <a:r>
-              <a:t>3. AI搭載の修理サポート機能</a:t>
+                  <a:srgbClr val="0F172A"/>
+                </a:solidFill>
+                <a:latin typeface="Noto Sans JP"/>
+              </a:defRPr>
+            </a:pPr>
+            <a:r>
+              <a:t>3. リアルタイムの状況共有とタスク管理</a:t>
+            </a:r>
+          </a:p>
+          <a:p>
+            <a:pPr>
+              <a:spcAft>
+                <a:spcPts val="2400"/>
+              </a:spcAft>
+              <a:defRPr sz="2200" b="1">
+                <a:solidFill>
+                  <a:srgbClr val="0F172A"/>
+                </a:solidFill>
+                <a:latin typeface="Noto Sans JP"/>
+              </a:defRPr>
+            </a:pPr>
+            <a:r>
+              <a:t>4. AI搭載の修理サポート機能</a:t>
             </a:r>
           </a:p>
         </p:txBody>
@@ -3786,7 +4155,7 @@
     <p:bg>
       <p:bgPr>
         <a:solidFill>
-          <a:srgbClr val="0B0E14"/>
+          <a:srgbClr val="F8FAFC"/>
         </a:solidFill>
         <a:effectLst/>
       </p:bgPr>
@@ -3806,8 +4175,8 @@
         </p:nvSpPr>
         <p:spPr>
           <a:xfrm>
-            <a:off x="685800" y="457200"/>
-            <a:ext cx="10820095" cy="731520"/>
+            <a:off x="685800" y="365760"/>
+            <a:ext cx="10820095" cy="914400"/>
           </a:xfrm>
           <a:prstGeom prst="rect">
             <a:avLst/>
@@ -3823,13 +4192,29 @@
             <a:pPr>
               <a:defRPr sz="2800" b="1">
                 <a:solidFill>
-                  <a:srgbClr val="3B82F6"/>
-                </a:solidFill>
-                <a:latin typeface="Yu Gothic"/>
+                  <a:srgbClr val="0F172A"/>
+                </a:solidFill>
+                <a:latin typeface="Noto Sans JP"/>
               </a:defRPr>
             </a:pPr>
             <a:r>
               <a:t>解決策：点検業務のデジタル化</a:t>
+            </a:r>
+          </a:p>
+          <a:p>
+            <a:pPr>
+              <a:spcBef>
+                <a:spcPts val="400"/>
+              </a:spcBef>
+              <a:defRPr sz="1500">
+                <a:solidFill>
+                  <a:srgbClr val="475569"/>
+                </a:solidFill>
+                <a:latin typeface="Noto Sans JP"/>
+              </a:defRPr>
+            </a:pPr>
+            <a:r>
+              <a:t>モバイル端末でその場入力・ペーパーレス化</a:t>
             </a:r>
           </a:p>
         </p:txBody>
@@ -3843,7 +4228,7 @@
         <p:spPr>
           <a:xfrm>
             <a:off x="685800" y="1645920"/>
-            <a:ext cx="4114800" cy="4114800"/>
+            <a:ext cx="5303520" cy="4572000"/>
           </a:xfrm>
           <a:prstGeom prst="rect">
             <a:avLst/>
@@ -3855,36 +4240,37 @@
             <a:spAutoFit/>
           </a:bodyPr>
           <a:lstStyle/>
+          <a:p/>
           <a:p>
             <a:pPr>
               <a:spcAft>
-                <a:spcPts val="1000"/>
+                <a:spcPts val="1200"/>
               </a:spcAft>
-              <a:defRPr sz="1400" b="1">
-                <a:solidFill>
-                  <a:srgbClr val="F3F4F6"/>
-                </a:solidFill>
-                <a:latin typeface="Yu Gothic"/>
-              </a:defRPr>
-            </a:pPr>
-            <a:r>
-              <a:t>📱 タブレットやスマホでの入力: 現場作業を行いながらその場から直接アプリに入力し提出可能。</a:t>
+              <a:defRPr sz="1700">
+                <a:solidFill>
+                  <a:srgbClr val="0F172A"/>
+                </a:solidFill>
+                <a:latin typeface="Noto Sans JP"/>
+              </a:defRPr>
+            </a:pPr>
+            <a:r>
+              <a:t>📱 現場でのモバイル入力: スマホやタブレットから直接点検表を入力。転記ミスや紛失を防止します。</a:t>
             </a:r>
           </a:p>
           <a:p>
             <a:pPr>
               <a:spcAft>
-                <a:spcPts val="1000"/>
+                <a:spcPts val="1200"/>
               </a:spcAft>
-              <a:defRPr sz="1400">
-                <a:solidFill>
-                  <a:srgbClr val="F3F4F6"/>
-                </a:solidFill>
-                <a:latin typeface="Yu Gothic"/>
-              </a:defRPr>
-            </a:pPr>
-            <a:r>
-              <a:t>🔒 データの安全な保存: 転記ミスや紛失を解消し、すべての点検結果は即座にデジタルデータとして安全に保存。</a:t>
+              <a:defRPr sz="1700">
+                <a:solidFill>
+                  <a:srgbClr val="0F172A"/>
+                </a:solidFill>
+                <a:latin typeface="Noto Sans JP"/>
+              </a:defRPr>
+            </a:pPr>
+            <a:r>
+              <a:t>☁️ 検索可能な履歴の蓄積: 点検データや過去の不具合履歴がクラウドへ保存され、いつでも検索可能です。</a:t>
             </a:r>
           </a:p>
         </p:txBody>
@@ -3905,8 +4291,8 @@
         </p:blipFill>
         <p:spPr>
           <a:xfrm>
-            <a:off x="5120640" y="1463040"/>
-            <a:ext cx="6400800" cy="4000500"/>
+            <a:off x="6217920" y="1645920"/>
+            <a:ext cx="5212080" cy="3257550"/>
           </a:xfrm>
           <a:prstGeom prst="rect">
             <a:avLst/>
@@ -3927,7 +4313,7 @@
     <p:bg>
       <p:bgPr>
         <a:solidFill>
-          <a:srgbClr val="0B0E14"/>
+          <a:srgbClr val="F8FAFC"/>
         </a:solidFill>
         <a:effectLst/>
       </p:bgPr>
@@ -3947,8 +4333,8 @@
         </p:nvSpPr>
         <p:spPr>
           <a:xfrm>
-            <a:off x="685800" y="457200"/>
-            <a:ext cx="10820095" cy="731520"/>
+            <a:off x="685800" y="365760"/>
+            <a:ext cx="10820095" cy="914400"/>
           </a:xfrm>
           <a:prstGeom prst="rect">
             <a:avLst/>
@@ -3964,13 +4350,29 @@
             <a:pPr>
               <a:defRPr sz="2800" b="1">
                 <a:solidFill>
-                  <a:srgbClr val="3B82F6"/>
-                </a:solidFill>
-                <a:latin typeface="Yu Gothic"/>
+                  <a:srgbClr val="0F172A"/>
+                </a:solidFill>
+                <a:latin typeface="Noto Sans JP"/>
               </a:defRPr>
             </a:pPr>
             <a:r>
               <a:t>解決策：検索可能な履歴ログ</a:t>
+            </a:r>
+          </a:p>
+          <a:p>
+            <a:pPr>
+              <a:spcBef>
+                <a:spcPts val="400"/>
+              </a:spcBef>
+              <a:defRPr sz="1500">
+                <a:solidFill>
+                  <a:srgbClr val="475569"/>
+                </a:solidFill>
+                <a:latin typeface="Noto Sans JP"/>
+              </a:defRPr>
+            </a:pPr>
+            <a:r>
+              <a:t>過去の不具合や修理記録を瞬時に検索</a:t>
             </a:r>
           </a:p>
         </p:txBody>
@@ -3984,7 +4386,7 @@
         <p:spPr>
           <a:xfrm>
             <a:off x="685800" y="1645920"/>
-            <a:ext cx="4114800" cy="4114800"/>
+            <a:ext cx="5303520" cy="4572000"/>
           </a:xfrm>
           <a:prstGeom prst="rect">
             <a:avLst/>
@@ -3996,36 +4398,37 @@
             <a:spAutoFit/>
           </a:bodyPr>
           <a:lstStyle/>
+          <a:p/>
           <a:p>
             <a:pPr>
               <a:spcAft>
-                <a:spcPts val="1000"/>
+                <a:spcPts val="1200"/>
               </a:spcAft>
-              <a:defRPr sz="1400" b="1">
-                <a:solidFill>
-                  <a:srgbClr val="F3F4F6"/>
-                </a:solidFill>
-                <a:latin typeface="Yu Gothic"/>
-              </a:defRPr>
-            </a:pPr>
-            <a:r>
-              <a:t>🔍 過去ログの動的検索: 過去の不具合履歴や点検結果を、日付や設備名から瞬時に呼び出せる検索機能を搭載。</a:t>
+              <a:defRPr sz="1700">
+                <a:solidFill>
+                  <a:srgbClr val="0F172A"/>
+                </a:solidFill>
+                <a:latin typeface="Noto Sans JP"/>
+              </a:defRPr>
+            </a:pPr>
+            <a:r>
+              <a:t>🔍 即座のキーワード検索: 日付や設備名、症状を入力するだけで、過去の修理履歴をその場で参照できます。</a:t>
             </a:r>
           </a:p>
           <a:p>
             <a:pPr>
               <a:spcAft>
-                <a:spcPts val="1000"/>
+                <a:spcPts val="1200"/>
               </a:spcAft>
-              <a:defRPr sz="1400">
-                <a:solidFill>
-                  <a:srgbClr val="F3F4F6"/>
-                </a:solidFill>
-                <a:latin typeface="Yu Gothic"/>
-              </a:defRPr>
-            </a:pPr>
-            <a:r>
-              <a:t>📈 不具合履歴の可視化: 設備ごとに不具合発生パターンを蓄積し、同じトラブルの再発傾向をデジタル上で一目で把握。</a:t>
+              <a:defRPr sz="1700">
+                <a:solidFill>
+                  <a:srgbClr val="0F172A"/>
+                </a:solidFill>
+                <a:latin typeface="Noto Sans JP"/>
+              </a:defRPr>
+            </a:pPr>
+            <a:r>
+              <a:t>📊 再発トラブルの把握: 過去にどんな対応をしたかが可視化され、熟練者に頼らず迅速な対応を可能にします。</a:t>
             </a:r>
           </a:p>
         </p:txBody>
@@ -4046,8 +4449,8 @@
         </p:blipFill>
         <p:spPr>
           <a:xfrm>
-            <a:off x="5120640" y="1463040"/>
-            <a:ext cx="6400800" cy="4000500"/>
+            <a:off x="6217920" y="1645920"/>
+            <a:ext cx="5212080" cy="3257550"/>
           </a:xfrm>
           <a:prstGeom prst="rect">
             <a:avLst/>
@@ -4068,7 +4471,7 @@
     <p:bg>
       <p:bgPr>
         <a:solidFill>
-          <a:srgbClr val="0B0E14"/>
+          <a:srgbClr val="F8FAFC"/>
         </a:solidFill>
         <a:effectLst/>
       </p:bgPr>
@@ -4088,8 +4491,8 @@
         </p:nvSpPr>
         <p:spPr>
           <a:xfrm>
-            <a:off x="685800" y="457200"/>
-            <a:ext cx="10820095" cy="731520"/>
+            <a:off x="685800" y="365760"/>
+            <a:ext cx="10820095" cy="914400"/>
           </a:xfrm>
           <a:prstGeom prst="rect">
             <a:avLst/>
@@ -4105,13 +4508,29 @@
             <a:pPr>
               <a:defRPr sz="2800" b="1">
                 <a:solidFill>
-                  <a:srgbClr val="3B82F6"/>
-                </a:solidFill>
-                <a:latin typeface="Yu Gothic"/>
-              </a:defRPr>
-            </a:pPr>
-            <a:r>
-              <a:t>解決策：状況共有と管理</a:t>
+                  <a:srgbClr val="0F172A"/>
+                </a:solidFill>
+                <a:latin typeface="Noto Sans JP"/>
+              </a:defRPr>
+            </a:pPr>
+            <a:r>
+              <a:t>解決策：レイアウトマップによる視覚管理</a:t>
+            </a:r>
+          </a:p>
+          <a:p>
+            <a:pPr>
+              <a:spcBef>
+                <a:spcPts val="400"/>
+              </a:spcBef>
+              <a:defRPr sz="1500">
+                <a:solidFill>
+                  <a:srgbClr val="475569"/>
+                </a:solidFill>
+                <a:latin typeface="Noto Sans JP"/>
+              </a:defRPr>
+            </a:pPr>
+            <a:r>
+              <a:t>平面図上で設備配置と配線ルートを直感的に把握</a:t>
             </a:r>
           </a:p>
         </p:txBody>
@@ -4125,7 +4544,7 @@
         <p:spPr>
           <a:xfrm>
             <a:off x="685800" y="1645920"/>
-            <a:ext cx="4114800" cy="4114800"/>
+            <a:ext cx="5303520" cy="4572000"/>
           </a:xfrm>
           <a:prstGeom prst="rect">
             <a:avLst/>
@@ -4137,59 +4556,44 @@
             <a:spAutoFit/>
           </a:bodyPr>
           <a:lstStyle/>
+          <a:p/>
           <a:p>
             <a:pPr>
               <a:spcAft>
-                <a:spcPts val="1000"/>
+                <a:spcPts val="1200"/>
               </a:spcAft>
-              <a:defRPr sz="1400" b="1">
-                <a:solidFill>
-                  <a:srgbClr val="F3F4F6"/>
-                </a:solidFill>
-                <a:latin typeface="Yu Gothic"/>
-              </a:defRPr>
-            </a:pPr>
-            <a:r>
-              <a:t>⚙️ 自動タスク化: 点検表で「異常あり」と回答されると、システムが自動で修理タスクを作成し即座に登録。</a:t>
+              <a:defRPr sz="1700">
+                <a:solidFill>
+                  <a:srgbClr val="0F172A"/>
+                </a:solidFill>
+                <a:latin typeface="Noto Sans JP"/>
+              </a:defRPr>
+            </a:pPr>
+            <a:r>
+              <a:t>🗺️ インタラクティブマップ: ロボットやレギュレーター等の配置や異常ステータスを、マップ上で一目に視認可能。</a:t>
             </a:r>
           </a:p>
           <a:p>
             <a:pPr>
               <a:spcAft>
-                <a:spcPts val="1000"/>
+                <a:spcPts val="1200"/>
               </a:spcAft>
-              <a:defRPr sz="1400">
-                <a:solidFill>
-                  <a:srgbClr val="F3F4F6"/>
-                </a:solidFill>
-                <a:latin typeface="Yu Gothic"/>
-              </a:defRPr>
-            </a:pPr>
-            <a:r>
-              <a:t>🚨 LINE WORKSへの自動アラート: 重大な不具合が検知された場合、LINE WORKSへ自動で緊急通知を送信。</a:t>
-            </a:r>
-          </a:p>
-          <a:p>
-            <a:pPr>
-              <a:spcAft>
-                <a:spcPts val="1000"/>
-              </a:spcAft>
-              <a:defRPr sz="1400">
-                <a:solidFill>
-                  <a:srgbClr val="F3F4F6"/>
-                </a:solidFill>
-                <a:latin typeface="Yu Gothic"/>
-              </a:defRPr>
-            </a:pPr>
-            <a:r>
-              <a:t>🔄 リアルタイム同期: 修理の状況や掲示板の内容が、すべてのデバイス（モバイル・PC）へリアルタイムに同期。</a:t>
+              <a:defRPr sz="1700">
+                <a:solidFill>
+                  <a:srgbClr val="0F172A"/>
+                </a:solidFill>
+                <a:latin typeface="Noto Sans JP"/>
+              </a:defRPr>
+            </a:pPr>
+            <a:r>
+              <a:t>🔌 配線ルートの可視化: 機器をタップするだけで配線系統を表示し、トラブル箇所の特定をスピード化。</a:t>
             </a:r>
           </a:p>
         </p:txBody>
       </p:sp>
       <p:pic>
         <p:nvPicPr>
-          <p:cNvPr id="4" name="Picture 3" descr="app_bulletin.png"/>
+          <p:cNvPr id="4" name="Picture 3" descr="app_wire_map.png"/>
           <p:cNvPicPr>
             <a:picLocks noChangeAspect="1"/>
           </p:cNvPicPr>
@@ -4203,8 +4607,8 @@
         </p:blipFill>
         <p:spPr>
           <a:xfrm>
-            <a:off x="5120640" y="1463040"/>
-            <a:ext cx="6400800" cy="4000500"/>
+            <a:off x="6217920" y="1645920"/>
+            <a:ext cx="5212080" cy="3257550"/>
           </a:xfrm>
           <a:prstGeom prst="rect">
             <a:avLst/>
@@ -4225,7 +4629,7 @@
     <p:bg>
       <p:bgPr>
         <a:solidFill>
-          <a:srgbClr val="0B0E14"/>
+          <a:srgbClr val="F8FAFC"/>
         </a:solidFill>
         <a:effectLst/>
       </p:bgPr>
@@ -4245,8 +4649,8 @@
         </p:nvSpPr>
         <p:spPr>
           <a:xfrm>
-            <a:off x="685800" y="457200"/>
-            <a:ext cx="10820095" cy="731520"/>
+            <a:off x="685800" y="365760"/>
+            <a:ext cx="10820095" cy="914400"/>
           </a:xfrm>
           <a:prstGeom prst="rect">
             <a:avLst/>
@@ -4262,13 +4666,29 @@
             <a:pPr>
               <a:defRPr sz="2800" b="1">
                 <a:solidFill>
-                  <a:srgbClr val="3B82F6"/>
-                </a:solidFill>
-                <a:latin typeface="Yu Gothic"/>
-              </a:defRPr>
-            </a:pPr>
-            <a:r>
-              <a:t>解決策：AI修理サポート</a:t>
+                  <a:srgbClr val="0F172A"/>
+                </a:solidFill>
+                <a:latin typeface="Noto Sans JP"/>
+              </a:defRPr>
+            </a:pPr>
+            <a:r>
+              <a:t>解決策：状況共有と管理</a:t>
+            </a:r>
+          </a:p>
+          <a:p>
+            <a:pPr>
+              <a:spcBef>
+                <a:spcPts val="400"/>
+              </a:spcBef>
+              <a:defRPr sz="1500">
+                <a:solidFill>
+                  <a:srgbClr val="475569"/>
+                </a:solidFill>
+                <a:latin typeface="Noto Sans JP"/>
+              </a:defRPr>
+            </a:pPr>
+            <a:r>
+              <a:t>自動タスク登録とLINE WORKS通知で連絡漏れを防止</a:t>
             </a:r>
           </a:p>
         </p:txBody>
@@ -4282,7 +4702,7 @@
         <p:spPr>
           <a:xfrm>
             <a:off x="685800" y="1645920"/>
-            <a:ext cx="4114800" cy="4114800"/>
+            <a:ext cx="5303520" cy="4572000"/>
           </a:xfrm>
           <a:prstGeom prst="rect">
             <a:avLst/>
@@ -4294,59 +4714,44 @@
             <a:spAutoFit/>
           </a:bodyPr>
           <a:lstStyle/>
+          <a:p/>
           <a:p>
             <a:pPr>
               <a:spcAft>
-                <a:spcPts val="1000"/>
+                <a:spcPts val="1200"/>
               </a:spcAft>
-              <a:defRPr sz="1400" b="1">
-                <a:solidFill>
-                  <a:srgbClr val="F3F4F6"/>
-                </a:solidFill>
-                <a:latin typeface="Yu Gothic"/>
-              </a:defRPr>
-            </a:pPr>
-            <a:r>
-              <a:t>💬 自然言語でのスマート質問: 紙マニュアルをめくる代わりに、普段の言葉で質問可能（例：「ワイヤ送給がもたついている」）。</a:t>
+              <a:defRPr sz="1700">
+                <a:solidFill>
+                  <a:srgbClr val="0F172A"/>
+                </a:solidFill>
+                <a:latin typeface="Noto Sans JP"/>
+              </a:defRPr>
+            </a:pPr>
+            <a:r>
+              <a:t>🔔 自動タスク化＆通知: 異常「あり」と回答されると自動で修理タスクが登録され、LINE WORKSへ即座に緊急通知されます。</a:t>
             </a:r>
           </a:p>
           <a:p>
             <a:pPr>
               <a:spcAft>
-                <a:spcPts val="1000"/>
+                <a:spcPts val="1200"/>
               </a:spcAft>
-              <a:defRPr sz="1400">
-                <a:solidFill>
-                  <a:srgbClr val="F3F4F6"/>
-                </a:solidFill>
-                <a:latin typeface="Yu Gothic"/>
-              </a:defRPr>
-            </a:pPr>
-            <a:r>
-              <a:t>📖 引用元の提示: AIがマニュアルから関連箇所を読み取り、参照したページや項番を示しながら明確な回答。</a:t>
-            </a:r>
-          </a:p>
-          <a:p>
-            <a:pPr>
-              <a:spcAft>
-                <a:spcPts val="1000"/>
-              </a:spcAft>
-              <a:defRPr sz="1400">
-                <a:solidFill>
-                  <a:srgbClr val="F3F4F6"/>
-                </a:solidFill>
-                <a:latin typeface="Yu Gothic"/>
-              </a:defRPr>
-            </a:pPr>
-            <a:r>
-              <a:t>⚡ トラブル一次対応の迅速化: 直接先輩社員に聞いたり、電話をする手間を省き、その場で即時に一次対処が可能。</a:t>
+              <a:defRPr sz="1700">
+                <a:solidFill>
+                  <a:srgbClr val="0F172A"/>
+                </a:solidFill>
+                <a:latin typeface="Noto Sans JP"/>
+              </a:defRPr>
+            </a:pPr>
+            <a:r>
+              <a:t>🔄 全デバイス同期: 修理の進捗状況や掲示板の内容が、すべてのデバイス（モバイル・PC）へリアルタイムに同期されます。</a:t>
             </a:r>
           </a:p>
         </p:txBody>
       </p:sp>
       <p:pic>
         <p:nvPicPr>
-          <p:cNvPr id="4" name="Picture 3" descr="app_manuals.png"/>
+          <p:cNvPr id="4" name="Picture 3" descr="app_bulletin.png"/>
           <p:cNvPicPr>
             <a:picLocks noChangeAspect="1"/>
           </p:cNvPicPr>
@@ -4360,8 +4765,8 @@
         </p:blipFill>
         <p:spPr>
           <a:xfrm>
-            <a:off x="5120640" y="1463040"/>
-            <a:ext cx="6400800" cy="4000500"/>
+            <a:off x="6217920" y="1645920"/>
+            <a:ext cx="5212080" cy="3257550"/>
           </a:xfrm>
           <a:prstGeom prst="rect">
             <a:avLst/>
@@ -4382,7 +4787,7 @@
     <p:bg>
       <p:bgPr>
         <a:solidFill>
-          <a:srgbClr val="0B0E14"/>
+          <a:srgbClr val="F8FAFC"/>
         </a:solidFill>
         <a:effectLst/>
       </p:bgPr>
@@ -4402,8 +4807,8 @@
         </p:nvSpPr>
         <p:spPr>
           <a:xfrm>
-            <a:off x="685800" y="1371600"/>
-            <a:ext cx="10820095" cy="1371600"/>
+            <a:off x="685800" y="365760"/>
+            <a:ext cx="10820095" cy="914400"/>
           </a:xfrm>
           <a:prstGeom prst="rect">
             <a:avLst/>
@@ -4417,15 +4822,31 @@
           <a:lstStyle/>
           <a:p>
             <a:pPr>
-              <a:defRPr sz="4400" b="1">
-                <a:solidFill>
-                  <a:srgbClr val="3B82F6"/>
-                </a:solidFill>
-                <a:latin typeface="Yu Gothic"/>
-              </a:defRPr>
-            </a:pPr>
-            <a:r>
-              <a:t>成果と今後の展望</a:t>
+              <a:defRPr sz="2800" b="1">
+                <a:solidFill>
+                  <a:srgbClr val="0F172A"/>
+                </a:solidFill>
+                <a:latin typeface="Noto Sans JP"/>
+              </a:defRPr>
+            </a:pPr>
+            <a:r>
+              <a:t>解決策：AI修理サポート</a:t>
+            </a:r>
+          </a:p>
+          <a:p>
+            <a:pPr>
+              <a:spcBef>
+                <a:spcPts val="400"/>
+              </a:spcBef>
+              <a:defRPr sz="1500">
+                <a:solidFill>
+                  <a:srgbClr val="475569"/>
+                </a:solidFill>
+                <a:latin typeface="Noto Sans JP"/>
+              </a:defRPr>
+            </a:pPr>
+            <a:r>
+              <a:t>現場ですぐに頼れるAIアドバイザー機能</a:t>
             </a:r>
           </a:p>
         </p:txBody>
@@ -4438,8 +4859,8 @@
         </p:nvSpPr>
         <p:spPr>
           <a:xfrm>
-            <a:off x="685800" y="2926080"/>
-            <a:ext cx="10820095" cy="2743200"/>
+            <a:off x="685800" y="1645920"/>
+            <a:ext cx="5303520" cy="4572000"/>
           </a:xfrm>
           <a:prstGeom prst="rect">
             <a:avLst/>
@@ -4451,56 +4872,65 @@
             <a:spAutoFit/>
           </a:bodyPr>
           <a:lstStyle/>
+          <a:p/>
           <a:p>
             <a:pPr>
               <a:spcAft>
-                <a:spcPts val="2000"/>
+                <a:spcPts val="1200"/>
               </a:spcAft>
-              <a:defRPr sz="2200" b="1">
-                <a:solidFill>
-                  <a:srgbClr val="F3F4F6"/>
-                </a:solidFill>
-                <a:latin typeface="Yu Gothic"/>
-              </a:defRPr>
-            </a:pPr>
-            <a:r>
-              <a:t>1. データ主導のメンテナンス</a:t>
+              <a:defRPr sz="1700">
+                <a:solidFill>
+                  <a:srgbClr val="0F172A"/>
+                </a:solidFill>
+                <a:latin typeface="Noto Sans JP"/>
+              </a:defRPr>
+            </a:pPr>
+            <a:r>
+              <a:t>🤖 普段の言葉で質問応答: マニュアルをめくる代わりに、自然な言葉でトラブル症状を質問できます。</a:t>
             </a:r>
           </a:p>
           <a:p>
             <a:pPr>
               <a:spcAft>
-                <a:spcPts val="2000"/>
+                <a:spcPts val="1200"/>
               </a:spcAft>
-              <a:defRPr sz="2200" b="1">
-                <a:solidFill>
-                  <a:srgbClr val="F3F4F6"/>
-                </a:solidFill>
-                <a:latin typeface="Yu Gothic"/>
-              </a:defRPr>
-            </a:pPr>
-            <a:r>
-              <a:t>2. AI対応マニュアルの拡大</a:t>
-            </a:r>
-          </a:p>
-          <a:p>
-            <a:pPr>
-              <a:spcAft>
-                <a:spcPts val="2000"/>
-              </a:spcAft>
-              <a:defRPr sz="2200" b="1">
-                <a:solidFill>
-                  <a:srgbClr val="F3F4F6"/>
-                </a:solidFill>
-                <a:latin typeface="Yu Gothic"/>
-              </a:defRPr>
-            </a:pPr>
-            <a:r>
-              <a:t>3. 使うほど賢くなるAI学習ループ</a:t>
-            </a:r>
-          </a:p>
-        </p:txBody>
-      </p:sp>
+              <a:defRPr sz="1700">
+                <a:solidFill>
+                  <a:srgbClr val="0F172A"/>
+                </a:solidFill>
+                <a:latin typeface="Noto Sans JP"/>
+              </a:defRPr>
+            </a:pPr>
+            <a:r>
+              <a:t>📄 明確な引用元ページ提示: AIは取り込んだマニュアルを参照し、根拠となるページや項番を示して回答します。</a:t>
+            </a:r>
+          </a:p>
+        </p:txBody>
+      </p:sp>
+      <p:pic>
+        <p:nvPicPr>
+          <p:cNvPr id="4" name="Picture 3" descr="app_manuals.png"/>
+          <p:cNvPicPr>
+            <a:picLocks noChangeAspect="1"/>
+          </p:cNvPicPr>
+          <p:nvPr/>
+        </p:nvPicPr>
+        <p:blipFill>
+          <a:blip r:embed="rId2"/>
+          <a:stretch>
+            <a:fillRect/>
+          </a:stretch>
+        </p:blipFill>
+        <p:spPr>
+          <a:xfrm>
+            <a:off x="6217920" y="1645920"/>
+            <a:ext cx="5212080" cy="3257550"/>
+          </a:xfrm>
+          <a:prstGeom prst="rect">
+            <a:avLst/>
+          </a:prstGeom>
+        </p:spPr>
+      </p:pic>
     </p:spTree>
   </p:cSld>
   <p:clrMapOvr>
@@ -4515,7 +4945,7 @@
     <p:bg>
       <p:bgPr>
         <a:solidFill>
-          <a:srgbClr val="0B0E14"/>
+          <a:srgbClr val="F8FAFC"/>
         </a:solidFill>
         <a:effectLst/>
       </p:bgPr>
@@ -4535,8 +4965,8 @@
         </p:nvSpPr>
         <p:spPr>
           <a:xfrm>
-            <a:off x="685800" y="457200"/>
-            <a:ext cx="10820095" cy="731520"/>
+            <a:off x="685800" y="365760"/>
+            <a:ext cx="10820095" cy="914400"/>
           </a:xfrm>
           <a:prstGeom prst="rect">
             <a:avLst/>
@@ -4552,13 +4982,29 @@
             <a:pPr>
               <a:defRPr sz="2800" b="1">
                 <a:solidFill>
-                  <a:srgbClr val="3B82F6"/>
-                </a:solidFill>
-                <a:latin typeface="Yu Gothic"/>
-              </a:defRPr>
-            </a:pPr>
-            <a:r>
-              <a:t>今後の展望：データ主導の保全</a:t>
+                  <a:srgbClr val="0F172A"/>
+                </a:solidFill>
+                <a:latin typeface="Noto Sans JP"/>
+              </a:defRPr>
+            </a:pPr>
+            <a:r>
+              <a:t>成果と今後の展望</a:t>
+            </a:r>
+          </a:p>
+          <a:p>
+            <a:pPr>
+              <a:spcBef>
+                <a:spcPts val="400"/>
+              </a:spcBef>
+              <a:defRPr sz="1500">
+                <a:solidFill>
+                  <a:srgbClr val="475569"/>
+                </a:solidFill>
+                <a:latin typeface="Noto Sans JP"/>
+              </a:defRPr>
+            </a:pPr>
+            <a:r>
+              <a:t>さらなる現場改善に向けた3つのステップ</a:t>
             </a:r>
           </a:p>
         </p:txBody>
@@ -4571,8 +5017,8 @@
         </p:nvSpPr>
         <p:spPr>
           <a:xfrm>
-            <a:off x="685800" y="1645920"/>
-            <a:ext cx="5029200" cy="4114800"/>
+            <a:off x="2286000" y="1828800"/>
+            <a:ext cx="7619695" cy="4114800"/>
           </a:xfrm>
           <a:prstGeom prst="rect">
             <a:avLst/>
@@ -4587,120 +5033,49 @@
           <a:p>
             <a:pPr>
               <a:spcAft>
-                <a:spcPts val="1000"/>
+                <a:spcPts val="2400"/>
               </a:spcAft>
-              <a:defRPr sz="1400" b="1">
-                <a:solidFill>
-                  <a:srgbClr val="F3F4F6"/>
-                </a:solidFill>
-                <a:latin typeface="Yu Gothic"/>
-              </a:defRPr>
-            </a:pPr>
-            <a:r>
-              <a:t>📊 長期トレンドの統計分析: 蓄積された履歴を基に長期的な故障サイクルを分析し、最適なスケジュールメンテナンスを実現。</a:t>
+              <a:defRPr sz="2200" b="1">
+                <a:solidFill>
+                  <a:srgbClr val="0F172A"/>
+                </a:solidFill>
+                <a:latin typeface="Noto Sans JP"/>
+              </a:defRPr>
+            </a:pPr>
+            <a:r>
+              <a:t>1. データ主導の予防保全</a:t>
             </a:r>
           </a:p>
           <a:p>
             <a:pPr>
               <a:spcAft>
-                <a:spcPts val="1000"/>
+                <a:spcPts val="2400"/>
               </a:spcAft>
-              <a:defRPr sz="1400">
-                <a:solidFill>
-                  <a:srgbClr val="F3F4F6"/>
-                </a:solidFill>
-                <a:latin typeface="Yu Gothic"/>
-              </a:defRPr>
-            </a:pPr>
-            <a:r>
-              <a:t>🔩 溶接機コンジットライナー詰まり予測: 点検記録からワイヤ送給のもたつきや滑り、アーク切れの予兆を特定。</a:t>
+              <a:defRPr sz="2200" b="1">
+                <a:solidFill>
+                  <a:srgbClr val="0F172A"/>
+                </a:solidFill>
+                <a:latin typeface="Noto Sans JP"/>
+              </a:defRPr>
+            </a:pPr>
+            <a:r>
+              <a:t>2. AI対応マニュアルの拡大</a:t>
             </a:r>
           </a:p>
           <a:p>
             <a:pPr>
               <a:spcAft>
-                <a:spcPts val="1000"/>
+                <a:spcPts val="2400"/>
               </a:spcAft>
-              <a:defRPr sz="1400">
-                <a:solidFill>
-                  <a:srgbClr val="F3F4F6"/>
-                </a:solidFill>
-                <a:latin typeface="Yu Gothic"/>
-              </a:defRPr>
-            </a:pPr>
-            <a:r>
-              <a:t>⚙️ ドライブロールの摩耗管理: 金属粉の蓄積やロール摩耗時期をデータで特定し、最適なタイミングで交換を実施してアーク停止を防止。</a:t>
-            </a:r>
-          </a:p>
-        </p:txBody>
-      </p:sp>
-      <p:sp>
-        <p:nvSpPr>
-          <p:cNvPr id="4" name="TextBox 3"/>
-          <p:cNvSpPr txBox="1"/>
-          <p:nvPr/>
-        </p:nvSpPr>
-        <p:spPr>
-          <a:xfrm>
-            <a:off x="6217920" y="1645920"/>
-            <a:ext cx="5029200" cy="4114800"/>
-          </a:xfrm>
-          <a:prstGeom prst="rect">
-            <a:avLst/>
-          </a:prstGeom>
-          <a:noFill/>
-        </p:spPr>
-        <p:txBody>
-          <a:bodyPr wrap="square">
-            <a:spAutoFit/>
-          </a:bodyPr>
-          <a:lstStyle/>
-          <a:p>
-            <a:pPr>
-              <a:spcAft>
-                <a:spcPts val="1000"/>
-              </a:spcAft>
-              <a:defRPr sz="1400" b="1">
-                <a:solidFill>
-                  <a:srgbClr val="F3F4F6"/>
-                </a:solidFill>
-                <a:latin typeface="Yu Gothic"/>
-              </a:defRPr>
-            </a:pPr>
-            <a:r>
-              <a:t>🔴 ワイヤ送給のもたつき: 3回検出 [警告基準: 2回以上]</a:t>
-            </a:r>
-          </a:p>
-          <a:p>
-            <a:pPr>
-              <a:spcAft>
-                <a:spcPts val="1000"/>
-              </a:spcAft>
-              <a:defRPr sz="1400">
-                <a:solidFill>
-                  <a:srgbClr val="F3F4F6"/>
-                </a:solidFill>
-                <a:latin typeface="Yu Gothic"/>
-              </a:defRPr>
-            </a:pPr>
-            <a:r>
-              <a:t>🟡 ワイヤの滑り: 2回検出 [注意基準: 1回以上]</a:t>
-            </a:r>
-          </a:p>
-          <a:p>
-            <a:pPr>
-              <a:spcAft>
-                <a:spcPts val="1000"/>
-              </a:spcAft>
-              <a:defRPr sz="1400">
-                <a:solidFill>
-                  <a:srgbClr val="F3F4F6"/>
-                </a:solidFill>
-                <a:latin typeface="Yu Gothic"/>
-              </a:defRPr>
-            </a:pPr>
-            <a:r>
-              <a:t>🔧 推奨アクション: 点検記録より「もたつき」「滑り」の再発傾向を検知。金属粉による詰まりを防ぐため、次回の段取り替え時にライナー交換を推奨します。</a:t>
+              <a:defRPr sz="2200" b="1">
+                <a:solidFill>
+                  <a:srgbClr val="0F172A"/>
+                </a:solidFill>
+                <a:latin typeface="Noto Sans JP"/>
+              </a:defRPr>
+            </a:pPr>
+            <a:r>
+              <a:t>3. 使うほど賢くなるAI学習ループ</a:t>
             </a:r>
           </a:p>
         </p:txBody>

</xml_diff>

<commit_message>
Remove small sub-text across Slide 2 and solution slides, making titles large and prominent
</commit_message>
<xml_diff>
--- a/seibi_presentation.pptx
+++ b/seibi_presentation.pptx
@@ -3277,8 +3277,8 @@
         </p:nvSpPr>
         <p:spPr>
           <a:xfrm>
-            <a:off x="685800" y="1645920"/>
-            <a:ext cx="5303520" cy="4572000"/>
+            <a:off x="685800" y="2011680"/>
+            <a:ext cx="5303520" cy="4114800"/>
           </a:xfrm>
           <a:prstGeom prst="rect">
             <a:avLst/>
@@ -3294,9 +3294,9 @@
           <a:p>
             <a:pPr>
               <a:spcAft>
-                <a:spcPts val="1200"/>
+                <a:spcPts val="2000"/>
               </a:spcAft>
-              <a:defRPr sz="1700">
+              <a:defRPr sz="2200" b="1">
                 <a:solidFill>
                   <a:srgbClr val="0F172A"/>
                 </a:solidFill>
@@ -3304,15 +3304,15 @@
               </a:defRPr>
             </a:pPr>
             <a:r>
-              <a:t>⚡ 溶接機ログの予兆検知: 点検表の「ワイヤ送給のもたつき」や「滑り」の頻度から、ライン停止のサインを検知。</a:t>
+              <a:t>⚡ 溶接機ログの予兆検知</a:t>
             </a:r>
           </a:p>
           <a:p>
             <a:pPr>
               <a:spcAft>
-                <a:spcPts val="1200"/>
+                <a:spcPts val="2000"/>
               </a:spcAft>
-              <a:defRPr sz="1700">
+              <a:defRPr sz="2200" b="1">
                 <a:solidFill>
                   <a:srgbClr val="0F172A"/>
                 </a:solidFill>
@@ -3320,7 +3320,7 @@
               </a:defRPr>
             </a:pPr>
             <a:r>
-              <a:t>🛠️ 予測交換によるダウンタイムゼロ: ライナーの詰まりや駆動部の摩耗期を特定し、次回段取り時に交換してトラブルを防止。</a:t>
+              <a:t>🛠️ 予測交換によるダウンタイムゼロ</a:t>
             </a:r>
           </a:p>
         </p:txBody>
@@ -3365,9 +3365,9 @@
           <a:p>
             <a:pPr>
               <a:spcAft>
-                <a:spcPts val="1200"/>
+                <a:spcPts val="2000"/>
               </a:spcAft>
-              <a:defRPr sz="1700">
+              <a:defRPr sz="2200" b="1">
                 <a:solidFill>
                   <a:srgbClr val="0F172A"/>
                 </a:solidFill>
@@ -3381,9 +3381,9 @@
           <a:p>
             <a:pPr>
               <a:spcAft>
-                <a:spcPts val="1200"/>
+                <a:spcPts val="2000"/>
               </a:spcAft>
-              <a:defRPr sz="1700">
+              <a:defRPr sz="2200" b="1">
                 <a:solidFill>
                   <a:srgbClr val="0F172A"/>
                 </a:solidFill>
@@ -3397,9 +3397,9 @@
           <a:p>
             <a:pPr>
               <a:spcAft>
-                <a:spcPts val="1200"/>
+                <a:spcPts val="2000"/>
               </a:spcAft>
-              <a:defRPr sz="1700">
+              <a:defRPr sz="2200" b="1">
                 <a:solidFill>
                   <a:srgbClr val="0F172A"/>
                 </a:solidFill>
@@ -3498,7 +3498,7 @@
         </p:nvSpPr>
         <p:spPr>
           <a:xfrm>
-            <a:off x="685800" y="1645920"/>
+            <a:off x="685800" y="2011680"/>
             <a:ext cx="5212080" cy="2011680"/>
           </a:xfrm>
           <a:prstGeom prst="rect">
@@ -3513,10 +3513,7 @@
           <a:lstStyle/>
           <a:p>
             <a:pPr>
-              <a:spcAft>
-                <a:spcPts val="1000"/>
-              </a:spcAft>
-              <a:defRPr sz="2000" b="1">
+              <a:defRPr sz="2400" b="1">
                 <a:solidFill>
                   <a:srgbClr val="2563EB"/>
                 </a:solidFill>
@@ -3525,22 +3522,6 @@
             </a:pPr>
             <a:r>
               <a:t>📚 AI対応マニュアルの拡大</a:t>
-            </a:r>
-          </a:p>
-          <a:p>
-            <a:pPr>
-              <a:spcAft>
-                <a:spcPts val="1200"/>
-              </a:spcAft>
-              <a:defRPr sz="1700">
-                <a:solidFill>
-                  <a:srgbClr val="0F172A"/>
-                </a:solidFill>
-                <a:latin typeface="Noto Sans JP"/>
-              </a:defRPr>
-            </a:pPr>
-            <a:r>
-              <a:t>工場内のすべての主要設備の手順書・図面データをAIへ順次取り込み、全域をサポート可能にします。</a:t>
             </a:r>
           </a:p>
         </p:txBody>
@@ -3553,7 +3534,7 @@
         </p:nvSpPr>
         <p:spPr>
           <a:xfrm>
-            <a:off x="6217920" y="1645920"/>
+            <a:off x="6217920" y="2011680"/>
             <a:ext cx="5212080" cy="2011680"/>
           </a:xfrm>
           <a:prstGeom prst="rect">
@@ -3568,10 +3549,7 @@
           <a:lstStyle/>
           <a:p>
             <a:pPr>
-              <a:spcAft>
-                <a:spcPts val="1000"/>
-              </a:spcAft>
-              <a:defRPr sz="2000" b="1">
+              <a:defRPr sz="2400" b="1">
                 <a:solidFill>
                   <a:srgbClr val="059669"/>
                 </a:solidFill>
@@ -3580,22 +3558,6 @@
             </a:pPr>
             <a:r>
               <a:t>🔄 使うほど賢くなるAI学習ループ</a:t>
-            </a:r>
-          </a:p>
-          <a:p>
-            <a:pPr>
-              <a:spcAft>
-                <a:spcPts val="1200"/>
-              </a:spcAft>
-              <a:defRPr sz="1700">
-                <a:solidFill>
-                  <a:srgbClr val="0F172A"/>
-                </a:solidFill>
-                <a:latin typeface="Noto Sans JP"/>
-              </a:defRPr>
-            </a:pPr>
-            <a:r>
-              <a:t>質問ログとフィードバック（役に立ったか）を分析。良回答を保存・学習し、精度を向上させます。</a:t>
             </a:r>
           </a:p>
         </p:txBody>
@@ -3640,9 +3602,9 @@
           <a:p>
             <a:pPr>
               <a:spcAft>
-                <a:spcPts val="1200"/>
+                <a:spcPts val="2000"/>
               </a:spcAft>
-              <a:defRPr sz="1700">
+              <a:defRPr sz="2200" b="1">
                 <a:solidFill>
                   <a:srgbClr val="0F172A"/>
                 </a:solidFill>
@@ -3819,7 +3781,7 @@
         </p:nvSpPr>
         <p:spPr>
           <a:xfrm>
-            <a:off x="685800" y="1645920"/>
+            <a:off x="685800" y="2011680"/>
             <a:ext cx="3328416" cy="4114800"/>
           </a:xfrm>
           <a:prstGeom prst="rect">
@@ -3833,11 +3795,8 @@
           </a:bodyPr>
           <a:lstStyle/>
           <a:p>
-            <a:pPr>
-              <a:spcAft>
-                <a:spcPts val="1400"/>
-              </a:spcAft>
-              <a:defRPr sz="2000" b="1">
+            <a:pPr algn="ctr">
+              <a:defRPr sz="2800" b="1">
                 <a:solidFill>
                   <a:srgbClr val="2563EB"/>
                 </a:solidFill>
@@ -3846,22 +3805,6 @@
             </a:pPr>
             <a:r>
               <a:t>📁 履歴の散逸</a:t>
-            </a:r>
-          </a:p>
-          <a:p>
-            <a:pPr>
-              <a:lnSpc>
-                <a:spcPct val="140000"/>
-              </a:lnSpc>
-              <a:defRPr sz="1600">
-                <a:solidFill>
-                  <a:srgbClr val="0F172A"/>
-                </a:solidFill>
-                <a:latin typeface="Noto Sans JP"/>
-              </a:defRPr>
-            </a:pPr>
-            <a:r>
-              <a:t>手書きの点検表は提出後に保管または破棄され、検索可能なデジタル記録が残らない状態でした。</a:t>
             </a:r>
           </a:p>
         </p:txBody>
@@ -3874,7 +3817,7 @@
         </p:nvSpPr>
         <p:spPr>
           <a:xfrm>
-            <a:off x="4288536" y="1645920"/>
+            <a:off x="4288536" y="2011680"/>
             <a:ext cx="3328416" cy="4114800"/>
           </a:xfrm>
           <a:prstGeom prst="rect">
@@ -3888,11 +3831,8 @@
           </a:bodyPr>
           <a:lstStyle/>
           <a:p>
-            <a:pPr>
-              <a:spcAft>
-                <a:spcPts val="1400"/>
-              </a:spcAft>
-              <a:defRPr sz="2000" b="1">
+            <a:pPr algn="ctr">
+              <a:defRPr sz="2800" b="1">
                 <a:solidFill>
                   <a:srgbClr val="2563EB"/>
                 </a:solidFill>
@@ -3901,22 +3841,6 @@
             </a:pPr>
             <a:r>
               <a:t>🔄 追跡の困難</a:t>
-            </a:r>
-          </a:p>
-          <a:p>
-            <a:pPr>
-              <a:lnSpc>
-                <a:spcPct val="140000"/>
-              </a:lnSpc>
-              <a:defRPr sz="1600">
-                <a:solidFill>
-                  <a:srgbClr val="0F172A"/>
-                </a:solidFill>
-                <a:latin typeface="Noto Sans JP"/>
-              </a:defRPr>
-            </a:pPr>
-            <a:r>
-              <a:t>同じトラブルが繰り返し発生しても記憶に頼るしかなく、発見された異常が確実に修理されたか確認できませんでした。</a:t>
             </a:r>
           </a:p>
         </p:txBody>
@@ -3929,7 +3853,7 @@
         </p:nvSpPr>
         <p:spPr>
           <a:xfrm>
-            <a:off x="7891271" y="1645920"/>
+            <a:off x="7891271" y="2011680"/>
             <a:ext cx="3328416" cy="4114800"/>
           </a:xfrm>
           <a:prstGeom prst="rect">
@@ -3943,11 +3867,8 @@
           </a:bodyPr>
           <a:lstStyle/>
           <a:p>
-            <a:pPr>
-              <a:spcAft>
-                <a:spcPts val="1400"/>
-              </a:spcAft>
-              <a:defRPr sz="2000" b="1">
+            <a:pPr algn="ctr">
+              <a:defRPr sz="2800" b="1">
                 <a:solidFill>
                   <a:srgbClr val="2563EB"/>
                 </a:solidFill>
@@ -3956,22 +3877,6 @@
             </a:pPr>
             <a:r>
               <a:t>📖 作業の非効率</a:t>
-            </a:r>
-          </a:p>
-          <a:p>
-            <a:pPr>
-              <a:lnSpc>
-                <a:spcPct val="140000"/>
-              </a:lnSpc>
-              <a:defRPr sz="1600">
-                <a:solidFill>
-                  <a:srgbClr val="0F172A"/>
-                </a:solidFill>
-                <a:latin typeface="Noto Sans JP"/>
-              </a:defRPr>
-            </a:pPr>
-            <a:r>
-              <a:t>トラブル対応時に紙のマニュアルを探してめくるか、特定の人に質問するしか選択肢がありませんでした。</a:t>
             </a:r>
           </a:p>
         </p:txBody>
@@ -4227,8 +4132,8 @@
         </p:nvSpPr>
         <p:spPr>
           <a:xfrm>
-            <a:off x="685800" y="1645920"/>
-            <a:ext cx="5303520" cy="4572000"/>
+            <a:off x="685800" y="2011680"/>
+            <a:ext cx="5303520" cy="4114800"/>
           </a:xfrm>
           <a:prstGeom prst="rect">
             <a:avLst/>
@@ -4244,9 +4149,9 @@
           <a:p>
             <a:pPr>
               <a:spcAft>
-                <a:spcPts val="1200"/>
+                <a:spcPts val="2000"/>
               </a:spcAft>
-              <a:defRPr sz="1700">
+              <a:defRPr sz="2200" b="1">
                 <a:solidFill>
                   <a:srgbClr val="0F172A"/>
                 </a:solidFill>
@@ -4254,15 +4159,15 @@
               </a:defRPr>
             </a:pPr>
             <a:r>
-              <a:t>📱 現場でのモバイル入力: スマホやタブレットから直接点検表を入力。転記ミスや紛失を防止します。</a:t>
+              <a:t>📱 現場でのモバイル入力</a:t>
             </a:r>
           </a:p>
           <a:p>
             <a:pPr>
               <a:spcAft>
-                <a:spcPts val="1200"/>
+                <a:spcPts val="2000"/>
               </a:spcAft>
-              <a:defRPr sz="1700">
+              <a:defRPr sz="2200" b="1">
                 <a:solidFill>
                   <a:srgbClr val="0F172A"/>
                 </a:solidFill>
@@ -4270,7 +4175,7 @@
               </a:defRPr>
             </a:pPr>
             <a:r>
-              <a:t>☁️ 検索可能な履歴の蓄積: 点検データや過去の不具合履歴がクラウドへ保存され、いつでも検索可能です。</a:t>
+              <a:t>☁️ 検索可能な履歴の蓄積</a:t>
             </a:r>
           </a:p>
         </p:txBody>
@@ -4385,8 +4290,8 @@
         </p:nvSpPr>
         <p:spPr>
           <a:xfrm>
-            <a:off x="685800" y="1645920"/>
-            <a:ext cx="5303520" cy="4572000"/>
+            <a:off x="685800" y="2011680"/>
+            <a:ext cx="5303520" cy="4114800"/>
           </a:xfrm>
           <a:prstGeom prst="rect">
             <a:avLst/>
@@ -4402,9 +4307,9 @@
           <a:p>
             <a:pPr>
               <a:spcAft>
-                <a:spcPts val="1200"/>
+                <a:spcPts val="2000"/>
               </a:spcAft>
-              <a:defRPr sz="1700">
+              <a:defRPr sz="2200" b="1">
                 <a:solidFill>
                   <a:srgbClr val="0F172A"/>
                 </a:solidFill>
@@ -4412,15 +4317,15 @@
               </a:defRPr>
             </a:pPr>
             <a:r>
-              <a:t>🔍 即座のキーワード検索: 日付や設備名、症状を入力するだけで、過去の修理履歴をその場で参照できます。</a:t>
+              <a:t>🔍 即座のキーワード検索</a:t>
             </a:r>
           </a:p>
           <a:p>
             <a:pPr>
               <a:spcAft>
-                <a:spcPts val="1200"/>
+                <a:spcPts val="2000"/>
               </a:spcAft>
-              <a:defRPr sz="1700">
+              <a:defRPr sz="2200" b="1">
                 <a:solidFill>
                   <a:srgbClr val="0F172A"/>
                 </a:solidFill>
@@ -4428,7 +4333,7 @@
               </a:defRPr>
             </a:pPr>
             <a:r>
-              <a:t>📊 再発トラブルの把握: 過去にどんな対応をしたかが可視化され、熟練者に頼らず迅速な対応を可能にします。</a:t>
+              <a:t>📊 再発トラブルの把握</a:t>
             </a:r>
           </a:p>
         </p:txBody>
@@ -4543,8 +4448,8 @@
         </p:nvSpPr>
         <p:spPr>
           <a:xfrm>
-            <a:off x="685800" y="1645920"/>
-            <a:ext cx="5303520" cy="4572000"/>
+            <a:off x="685800" y="2011680"/>
+            <a:ext cx="5303520" cy="4114800"/>
           </a:xfrm>
           <a:prstGeom prst="rect">
             <a:avLst/>
@@ -4560,9 +4465,9 @@
           <a:p>
             <a:pPr>
               <a:spcAft>
-                <a:spcPts val="1200"/>
+                <a:spcPts val="2000"/>
               </a:spcAft>
-              <a:defRPr sz="1700">
+              <a:defRPr sz="2200" b="1">
                 <a:solidFill>
                   <a:srgbClr val="0F172A"/>
                 </a:solidFill>
@@ -4570,15 +4475,15 @@
               </a:defRPr>
             </a:pPr>
             <a:r>
-              <a:t>🗺️ インタラクティブマップ: ロボットやレギュレーター等の配置や異常ステータスを、マップ上で一目に視認可能。</a:t>
+              <a:t>🗺️ インタラクティブマップ</a:t>
             </a:r>
           </a:p>
           <a:p>
             <a:pPr>
               <a:spcAft>
-                <a:spcPts val="1200"/>
+                <a:spcPts val="2000"/>
               </a:spcAft>
-              <a:defRPr sz="1700">
+              <a:defRPr sz="2200" b="1">
                 <a:solidFill>
                   <a:srgbClr val="0F172A"/>
                 </a:solidFill>
@@ -4586,7 +4491,7 @@
               </a:defRPr>
             </a:pPr>
             <a:r>
-              <a:t>🔌 配線ルートの可視化: 機器をタップするだけで配線系統を表示し、トラブル箇所の特定をスピード化。</a:t>
+              <a:t>🔌 配線ルートの可視化</a:t>
             </a:r>
           </a:p>
         </p:txBody>
@@ -4701,8 +4606,8 @@
         </p:nvSpPr>
         <p:spPr>
           <a:xfrm>
-            <a:off x="685800" y="1645920"/>
-            <a:ext cx="5303520" cy="4572000"/>
+            <a:off x="685800" y="2011680"/>
+            <a:ext cx="5303520" cy="4114800"/>
           </a:xfrm>
           <a:prstGeom prst="rect">
             <a:avLst/>
@@ -4718,9 +4623,9 @@
           <a:p>
             <a:pPr>
               <a:spcAft>
-                <a:spcPts val="1200"/>
+                <a:spcPts val="2000"/>
               </a:spcAft>
-              <a:defRPr sz="1700">
+              <a:defRPr sz="2200" b="1">
                 <a:solidFill>
                   <a:srgbClr val="0F172A"/>
                 </a:solidFill>
@@ -4728,15 +4633,15 @@
               </a:defRPr>
             </a:pPr>
             <a:r>
-              <a:t>🔔 自動タスク化＆通知: 異常「あり」と回答されると自動で修理タスクが登録され、LINE WORKSへ即座に緊急通知されます。</a:t>
+              <a:t>🔔 自動タスク化＆通知</a:t>
             </a:r>
           </a:p>
           <a:p>
             <a:pPr>
               <a:spcAft>
-                <a:spcPts val="1200"/>
+                <a:spcPts val="2000"/>
               </a:spcAft>
-              <a:defRPr sz="1700">
+              <a:defRPr sz="2200" b="1">
                 <a:solidFill>
                   <a:srgbClr val="0F172A"/>
                 </a:solidFill>
@@ -4744,7 +4649,7 @@
               </a:defRPr>
             </a:pPr>
             <a:r>
-              <a:t>🔄 全デバイス同期: 修理の進捗状況や掲示板の内容が、すべてのデバイス（モバイル・PC）へリアルタイムに同期されます。</a:t>
+              <a:t>🔄 全デバイス同期</a:t>
             </a:r>
           </a:p>
         </p:txBody>
@@ -4859,8 +4764,8 @@
         </p:nvSpPr>
         <p:spPr>
           <a:xfrm>
-            <a:off x="685800" y="1645920"/>
-            <a:ext cx="5303520" cy="4572000"/>
+            <a:off x="685800" y="2011680"/>
+            <a:ext cx="5303520" cy="4114800"/>
           </a:xfrm>
           <a:prstGeom prst="rect">
             <a:avLst/>
@@ -4876,9 +4781,9 @@
           <a:p>
             <a:pPr>
               <a:spcAft>
-                <a:spcPts val="1200"/>
+                <a:spcPts val="2000"/>
               </a:spcAft>
-              <a:defRPr sz="1700">
+              <a:defRPr sz="2200" b="1">
                 <a:solidFill>
                   <a:srgbClr val="0F172A"/>
                 </a:solidFill>
@@ -4886,15 +4791,15 @@
               </a:defRPr>
             </a:pPr>
             <a:r>
-              <a:t>🤖 普段の言葉で質問応答: マニュアルをめくる代わりに、自然な言葉でトラブル症状を質問できます。</a:t>
+              <a:t>🤖 普段の言葉で質問応答</a:t>
             </a:r>
           </a:p>
           <a:p>
             <a:pPr>
               <a:spcAft>
-                <a:spcPts val="1200"/>
+                <a:spcPts val="2000"/>
               </a:spcAft>
-              <a:defRPr sz="1700">
+              <a:defRPr sz="2200" b="1">
                 <a:solidFill>
                   <a:srgbClr val="0F172A"/>
                 </a:solidFill>
@@ -4902,7 +4807,7 @@
               </a:defRPr>
             </a:pPr>
             <a:r>
-              <a:t>📄 明確な引用元ページ提示: AIは取り込んだマニュアルを参照し、根拠となるページや項番を示して回答します。</a:t>
+              <a:t>📄 明確な引用元ページ提示</a:t>
             </a:r>
           </a:p>
         </p:txBody>

</xml_diff>